<commit_message>
Refine visualization layouts and Power BI report
Co-authored-by: Copilot <223556219+Copilot@users.noreply.github.com>
</commit_message>
<xml_diff>
--- a/data/raw/Marine_Microplastic_Pollution_Case_Study_Presentation.pptx
+++ b/data/raw/Marine_Microplastic_Pollution_Case_Study_Presentation.pptx
@@ -5,22 +5,22 @@
     <p:sldMasterId id="2147483648" r:id="rId1"/>
   </p:sldMasterIdLst>
   <p:sldIdLst>
-    <p:sldId id="256" r:id="rId7"/>
-    <p:sldId id="257" r:id="rId8"/>
-    <p:sldId id="258" r:id="rId9"/>
-    <p:sldId id="259" r:id="rId10"/>
-    <p:sldId id="260" r:id="rId11"/>
-    <p:sldId id="261" r:id="rId12"/>
-    <p:sldId id="262" r:id="rId13"/>
-    <p:sldId id="263" r:id="rId14"/>
-    <p:sldId id="264" r:id="rId15"/>
-    <p:sldId id="265" r:id="rId16"/>
-    <p:sldId id="266" r:id="rId17"/>
-    <p:sldId id="267" r:id="rId18"/>
-    <p:sldId id="268" r:id="rId19"/>
-    <p:sldId id="269" r:id="rId20"/>
+    <p:sldId id="256" r:id="rId2"/>
+    <p:sldId id="257" r:id="rId3"/>
+    <p:sldId id="258" r:id="rId4"/>
+    <p:sldId id="259" r:id="rId5"/>
+    <p:sldId id="260" r:id="rId6"/>
+    <p:sldId id="261" r:id="rId7"/>
+    <p:sldId id="262" r:id="rId8"/>
+    <p:sldId id="263" r:id="rId9"/>
+    <p:sldId id="264" r:id="rId10"/>
+    <p:sldId id="265" r:id="rId11"/>
+    <p:sldId id="266" r:id="rId12"/>
+    <p:sldId id="267" r:id="rId13"/>
+    <p:sldId id="268" r:id="rId14"/>
+    <p:sldId id="269" r:id="rId15"/>
   </p:sldIdLst>
-  <p:sldSz cx="12191695" cy="6858000" type="screen4x3"/>
+  <p:sldSz cx="12192000" cy="6858000"/>
   <p:notesSz cx="6858000" cy="9144000"/>
   <p:defaultTextStyle>
     <a:defPPr>
@@ -117,6 +117,22 @@
       </a:defRPr>
     </a:lvl9pPr>
   </p:defaultTextStyle>
+  <p:extLst>
+    <p:ext uri="{EFAFB233-063F-42B5-8137-9DF3F51BA10A}">
+      <p15:sldGuideLst xmlns:p15="http://schemas.microsoft.com/office/powerpoint/2012/main">
+        <p15:guide id="1" orient="horz" pos="2160">
+          <p15:clr>
+            <a:srgbClr val="A4A3A4"/>
+          </p15:clr>
+        </p15:guide>
+        <p15:guide id="2" pos="2880">
+          <p15:clr>
+            <a:srgbClr val="A4A3A4"/>
+          </p15:clr>
+        </p15:guide>
+      </p15:sldGuideLst>
+    </p:ext>
+  </p:extLst>
 </p:presentation>
 </file>
 
@@ -158,10 +174,9 @@
           <a:lstStyle/>
           <a:p>
             <a:r>
-              <a:rPr lang="en-US" smtClean="0"/>
+              <a:rPr lang="en-US"/>
               <a:t>Click to edit Master title style</a:t>
             </a:r>
-            <a:endParaRPr lang="en-US"/>
           </a:p>
         </p:txBody>
       </p:sp>
@@ -277,10 +292,9 @@
           </a:lstStyle>
           <a:p>
             <a:r>
-              <a:rPr lang="en-US" smtClean="0"/>
+              <a:rPr lang="en-US"/>
               <a:t>Click to edit Master subtitle style</a:t>
             </a:r>
-            <a:endParaRPr lang="en-US"/>
           </a:p>
         </p:txBody>
       </p:sp>
@@ -301,7 +315,7 @@
           <a:p>
             <a:fld id="{5BCAD085-E8A6-8845-BD4E-CB4CCA059FC4}" type="datetimeFigureOut">
               <a:rPr lang="en-US" smtClean="0"/>
-              <a:t>1/27/13</a:t>
+              <a:t>10/20/2026</a:t>
             </a:fld>
             <a:endParaRPr lang="en-US"/>
           </a:p>
@@ -395,10 +409,9 @@
           <a:lstStyle/>
           <a:p>
             <a:r>
-              <a:rPr lang="en-US" smtClean="0"/>
+              <a:rPr lang="en-US"/>
               <a:t>Click to edit Master title style</a:t>
             </a:r>
-            <a:endParaRPr lang="en-US"/>
           </a:p>
         </p:txBody>
       </p:sp>
@@ -419,38 +432,37 @@
           <a:p>
             <a:pPr lvl="0"/>
             <a:r>
-              <a:rPr lang="en-US" smtClean="0"/>
+              <a:rPr lang="en-US"/>
               <a:t>Click to edit Master text styles</a:t>
             </a:r>
           </a:p>
           <a:p>
             <a:pPr lvl="1"/>
             <a:r>
-              <a:rPr lang="en-US" smtClean="0"/>
+              <a:rPr lang="en-US"/>
               <a:t>Second level</a:t>
             </a:r>
           </a:p>
           <a:p>
             <a:pPr lvl="2"/>
             <a:r>
-              <a:rPr lang="en-US" smtClean="0"/>
+              <a:rPr lang="en-US"/>
               <a:t>Third level</a:t>
             </a:r>
           </a:p>
           <a:p>
             <a:pPr lvl="3"/>
             <a:r>
-              <a:rPr lang="en-US" smtClean="0"/>
+              <a:rPr lang="en-US"/>
               <a:t>Fourth level</a:t>
             </a:r>
           </a:p>
           <a:p>
             <a:pPr lvl="4"/>
             <a:r>
-              <a:rPr lang="en-US" smtClean="0"/>
+              <a:rPr lang="en-US"/>
               <a:t>Fifth level</a:t>
             </a:r>
-            <a:endParaRPr lang="en-US"/>
           </a:p>
         </p:txBody>
       </p:sp>
@@ -471,7 +483,7 @@
           <a:p>
             <a:fld id="{5BCAD085-E8A6-8845-BD4E-CB4CCA059FC4}" type="datetimeFigureOut">
               <a:rPr lang="en-US" smtClean="0"/>
-              <a:t>1/27/13</a:t>
+              <a:t>10/20/2026</a:t>
             </a:fld>
             <a:endParaRPr lang="en-US"/>
           </a:p>
@@ -570,10 +582,9 @@
           <a:lstStyle/>
           <a:p>
             <a:r>
-              <a:rPr lang="en-US" smtClean="0"/>
+              <a:rPr lang="en-US"/>
               <a:t>Click to edit Master title style</a:t>
             </a:r>
-            <a:endParaRPr lang="en-US"/>
           </a:p>
         </p:txBody>
       </p:sp>
@@ -599,38 +610,37 @@
           <a:p>
             <a:pPr lvl="0"/>
             <a:r>
-              <a:rPr lang="en-US" smtClean="0"/>
+              <a:rPr lang="en-US"/>
               <a:t>Click to edit Master text styles</a:t>
             </a:r>
           </a:p>
           <a:p>
             <a:pPr lvl="1"/>
             <a:r>
-              <a:rPr lang="en-US" smtClean="0"/>
+              <a:rPr lang="en-US"/>
               <a:t>Second level</a:t>
             </a:r>
           </a:p>
           <a:p>
             <a:pPr lvl="2"/>
             <a:r>
-              <a:rPr lang="en-US" smtClean="0"/>
+              <a:rPr lang="en-US"/>
               <a:t>Third level</a:t>
             </a:r>
           </a:p>
           <a:p>
             <a:pPr lvl="3"/>
             <a:r>
-              <a:rPr lang="en-US" smtClean="0"/>
+              <a:rPr lang="en-US"/>
               <a:t>Fourth level</a:t>
             </a:r>
           </a:p>
           <a:p>
             <a:pPr lvl="4"/>
             <a:r>
-              <a:rPr lang="en-US" smtClean="0"/>
+              <a:rPr lang="en-US"/>
               <a:t>Fifth level</a:t>
             </a:r>
-            <a:endParaRPr lang="en-US"/>
           </a:p>
         </p:txBody>
       </p:sp>
@@ -651,7 +661,7 @@
           <a:p>
             <a:fld id="{5BCAD085-E8A6-8845-BD4E-CB4CCA059FC4}" type="datetimeFigureOut">
               <a:rPr lang="en-US" smtClean="0"/>
-              <a:t>1/27/13</a:t>
+              <a:t>10/20/2026</a:t>
             </a:fld>
             <a:endParaRPr lang="en-US"/>
           </a:p>
@@ -745,10 +755,9 @@
           <a:lstStyle/>
           <a:p>
             <a:r>
-              <a:rPr lang="en-US" smtClean="0"/>
+              <a:rPr lang="en-US"/>
               <a:t>Click to edit Master title style</a:t>
             </a:r>
-            <a:endParaRPr lang="en-US"/>
           </a:p>
         </p:txBody>
       </p:sp>
@@ -769,38 +778,37 @@
           <a:p>
             <a:pPr lvl="0"/>
             <a:r>
-              <a:rPr lang="en-US" smtClean="0"/>
+              <a:rPr lang="en-US"/>
               <a:t>Click to edit Master text styles</a:t>
             </a:r>
           </a:p>
           <a:p>
             <a:pPr lvl="1"/>
             <a:r>
-              <a:rPr lang="en-US" smtClean="0"/>
+              <a:rPr lang="en-US"/>
               <a:t>Second level</a:t>
             </a:r>
           </a:p>
           <a:p>
             <a:pPr lvl="2"/>
             <a:r>
-              <a:rPr lang="en-US" smtClean="0"/>
+              <a:rPr lang="en-US"/>
               <a:t>Third level</a:t>
             </a:r>
           </a:p>
           <a:p>
             <a:pPr lvl="3"/>
             <a:r>
-              <a:rPr lang="en-US" smtClean="0"/>
+              <a:rPr lang="en-US"/>
               <a:t>Fourth level</a:t>
             </a:r>
           </a:p>
           <a:p>
             <a:pPr lvl="4"/>
             <a:r>
-              <a:rPr lang="en-US" smtClean="0"/>
+              <a:rPr lang="en-US"/>
               <a:t>Fifth level</a:t>
             </a:r>
-            <a:endParaRPr lang="en-US"/>
           </a:p>
         </p:txBody>
       </p:sp>
@@ -821,7 +829,7 @@
           <a:p>
             <a:fld id="{5BCAD085-E8A6-8845-BD4E-CB4CCA059FC4}" type="datetimeFigureOut">
               <a:rPr lang="en-US" smtClean="0"/>
-              <a:t>1/27/13</a:t>
+              <a:t>10/20/2026</a:t>
             </a:fld>
             <a:endParaRPr lang="en-US"/>
           </a:p>
@@ -924,10 +932,9 @@
           </a:lstStyle>
           <a:p>
             <a:r>
-              <a:rPr lang="en-US" smtClean="0"/>
+              <a:rPr lang="en-US"/>
               <a:t>Click to edit Master title style</a:t>
             </a:r>
-            <a:endParaRPr lang="en-US"/>
           </a:p>
         </p:txBody>
       </p:sp>
@@ -1044,7 +1051,7 @@
           <a:p>
             <a:pPr lvl="0"/>
             <a:r>
-              <a:rPr lang="en-US" smtClean="0"/>
+              <a:rPr lang="en-US"/>
               <a:t>Click to edit Master text styles</a:t>
             </a:r>
           </a:p>
@@ -1067,7 +1074,7 @@
           <a:p>
             <a:fld id="{5BCAD085-E8A6-8845-BD4E-CB4CCA059FC4}" type="datetimeFigureOut">
               <a:rPr lang="en-US" smtClean="0"/>
-              <a:t>1/27/13</a:t>
+              <a:t>10/20/2026</a:t>
             </a:fld>
             <a:endParaRPr lang="en-US"/>
           </a:p>
@@ -1161,10 +1168,9 @@
           <a:lstStyle/>
           <a:p>
             <a:r>
-              <a:rPr lang="en-US" smtClean="0"/>
+              <a:rPr lang="en-US"/>
               <a:t>Click to edit Master title style</a:t>
             </a:r>
-            <a:endParaRPr lang="en-US"/>
           </a:p>
         </p:txBody>
       </p:sp>
@@ -1218,38 +1224,37 @@
           <a:p>
             <a:pPr lvl="0"/>
             <a:r>
-              <a:rPr lang="en-US" smtClean="0"/>
+              <a:rPr lang="en-US"/>
               <a:t>Click to edit Master text styles</a:t>
             </a:r>
           </a:p>
           <a:p>
             <a:pPr lvl="1"/>
             <a:r>
-              <a:rPr lang="en-US" smtClean="0"/>
+              <a:rPr lang="en-US"/>
               <a:t>Second level</a:t>
             </a:r>
           </a:p>
           <a:p>
             <a:pPr lvl="2"/>
             <a:r>
-              <a:rPr lang="en-US" smtClean="0"/>
+              <a:rPr lang="en-US"/>
               <a:t>Third level</a:t>
             </a:r>
           </a:p>
           <a:p>
             <a:pPr lvl="3"/>
             <a:r>
-              <a:rPr lang="en-US" smtClean="0"/>
+              <a:rPr lang="en-US"/>
               <a:t>Fourth level</a:t>
             </a:r>
           </a:p>
           <a:p>
             <a:pPr lvl="4"/>
             <a:r>
-              <a:rPr lang="en-US" smtClean="0"/>
+              <a:rPr lang="en-US"/>
               <a:t>Fifth level</a:t>
             </a:r>
-            <a:endParaRPr lang="en-US"/>
           </a:p>
         </p:txBody>
       </p:sp>
@@ -1303,38 +1308,37 @@
           <a:p>
             <a:pPr lvl="0"/>
             <a:r>
-              <a:rPr lang="en-US" smtClean="0"/>
+              <a:rPr lang="en-US"/>
               <a:t>Click to edit Master text styles</a:t>
             </a:r>
           </a:p>
           <a:p>
             <a:pPr lvl="1"/>
             <a:r>
-              <a:rPr lang="en-US" smtClean="0"/>
+              <a:rPr lang="en-US"/>
               <a:t>Second level</a:t>
             </a:r>
           </a:p>
           <a:p>
             <a:pPr lvl="2"/>
             <a:r>
-              <a:rPr lang="en-US" smtClean="0"/>
+              <a:rPr lang="en-US"/>
               <a:t>Third level</a:t>
             </a:r>
           </a:p>
           <a:p>
             <a:pPr lvl="3"/>
             <a:r>
-              <a:rPr lang="en-US" smtClean="0"/>
+              <a:rPr lang="en-US"/>
               <a:t>Fourth level</a:t>
             </a:r>
           </a:p>
           <a:p>
             <a:pPr lvl="4"/>
             <a:r>
-              <a:rPr lang="en-US" smtClean="0"/>
+              <a:rPr lang="en-US"/>
               <a:t>Fifth level</a:t>
             </a:r>
-            <a:endParaRPr lang="en-US"/>
           </a:p>
         </p:txBody>
       </p:sp>
@@ -1355,7 +1359,7 @@
           <a:p>
             <a:fld id="{5BCAD085-E8A6-8845-BD4E-CB4CCA059FC4}" type="datetimeFigureOut">
               <a:rPr lang="en-US" smtClean="0"/>
-              <a:t>1/27/13</a:t>
+              <a:t>10/20/2026</a:t>
             </a:fld>
             <a:endParaRPr lang="en-US"/>
           </a:p>
@@ -1453,10 +1457,9 @@
           </a:lstStyle>
           <a:p>
             <a:r>
-              <a:rPr lang="en-US" smtClean="0"/>
+              <a:rPr lang="en-US"/>
               <a:t>Click to edit Master title style</a:t>
             </a:r>
-            <a:endParaRPr lang="en-US"/>
           </a:p>
         </p:txBody>
       </p:sp>
@@ -1519,7 +1522,7 @@
           <a:p>
             <a:pPr lvl="0"/>
             <a:r>
-              <a:rPr lang="en-US" smtClean="0"/>
+              <a:rPr lang="en-US"/>
               <a:t>Click to edit Master text styles</a:t>
             </a:r>
           </a:p>
@@ -1575,38 +1578,37 @@
           <a:p>
             <a:pPr lvl="0"/>
             <a:r>
-              <a:rPr lang="en-US" smtClean="0"/>
+              <a:rPr lang="en-US"/>
               <a:t>Click to edit Master text styles</a:t>
             </a:r>
           </a:p>
           <a:p>
             <a:pPr lvl="1"/>
             <a:r>
-              <a:rPr lang="en-US" smtClean="0"/>
+              <a:rPr lang="en-US"/>
               <a:t>Second level</a:t>
             </a:r>
           </a:p>
           <a:p>
             <a:pPr lvl="2"/>
             <a:r>
-              <a:rPr lang="en-US" smtClean="0"/>
+              <a:rPr lang="en-US"/>
               <a:t>Third level</a:t>
             </a:r>
           </a:p>
           <a:p>
             <a:pPr lvl="3"/>
             <a:r>
-              <a:rPr lang="en-US" smtClean="0"/>
+              <a:rPr lang="en-US"/>
               <a:t>Fourth level</a:t>
             </a:r>
           </a:p>
           <a:p>
             <a:pPr lvl="4"/>
             <a:r>
-              <a:rPr lang="en-US" smtClean="0"/>
+              <a:rPr lang="en-US"/>
               <a:t>Fifth level</a:t>
             </a:r>
-            <a:endParaRPr lang="en-US"/>
           </a:p>
         </p:txBody>
       </p:sp>
@@ -1669,7 +1671,7 @@
           <a:p>
             <a:pPr lvl="0"/>
             <a:r>
-              <a:rPr lang="en-US" smtClean="0"/>
+              <a:rPr lang="en-US"/>
               <a:t>Click to edit Master text styles</a:t>
             </a:r>
           </a:p>
@@ -1725,38 +1727,37 @@
           <a:p>
             <a:pPr lvl="0"/>
             <a:r>
-              <a:rPr lang="en-US" smtClean="0"/>
+              <a:rPr lang="en-US"/>
               <a:t>Click to edit Master text styles</a:t>
             </a:r>
           </a:p>
           <a:p>
             <a:pPr lvl="1"/>
             <a:r>
-              <a:rPr lang="en-US" smtClean="0"/>
+              <a:rPr lang="en-US"/>
               <a:t>Second level</a:t>
             </a:r>
           </a:p>
           <a:p>
             <a:pPr lvl="2"/>
             <a:r>
-              <a:rPr lang="en-US" smtClean="0"/>
+              <a:rPr lang="en-US"/>
               <a:t>Third level</a:t>
             </a:r>
           </a:p>
           <a:p>
             <a:pPr lvl="3"/>
             <a:r>
-              <a:rPr lang="en-US" smtClean="0"/>
+              <a:rPr lang="en-US"/>
               <a:t>Fourth level</a:t>
             </a:r>
           </a:p>
           <a:p>
             <a:pPr lvl="4"/>
             <a:r>
-              <a:rPr lang="en-US" smtClean="0"/>
+              <a:rPr lang="en-US"/>
               <a:t>Fifth level</a:t>
             </a:r>
-            <a:endParaRPr lang="en-US"/>
           </a:p>
         </p:txBody>
       </p:sp>
@@ -1777,7 +1778,7 @@
           <a:p>
             <a:fld id="{5BCAD085-E8A6-8845-BD4E-CB4CCA059FC4}" type="datetimeFigureOut">
               <a:rPr lang="en-US" smtClean="0"/>
-              <a:t>1/27/13</a:t>
+              <a:t>10/20/2026</a:t>
             </a:fld>
             <a:endParaRPr lang="en-US"/>
           </a:p>
@@ -1871,10 +1872,9 @@
           <a:lstStyle/>
           <a:p>
             <a:r>
-              <a:rPr lang="en-US" smtClean="0"/>
+              <a:rPr lang="en-US"/>
               <a:t>Click to edit Master title style</a:t>
             </a:r>
-            <a:endParaRPr lang="en-US"/>
           </a:p>
         </p:txBody>
       </p:sp>
@@ -1895,7 +1895,7 @@
           <a:p>
             <a:fld id="{5BCAD085-E8A6-8845-BD4E-CB4CCA059FC4}" type="datetimeFigureOut">
               <a:rPr lang="en-US" smtClean="0"/>
-              <a:t>1/27/13</a:t>
+              <a:t>10/20/2026</a:t>
             </a:fld>
             <a:endParaRPr lang="en-US"/>
           </a:p>
@@ -1990,7 +1990,7 @@
           <a:p>
             <a:fld id="{5BCAD085-E8A6-8845-BD4E-CB4CCA059FC4}" type="datetimeFigureOut">
               <a:rPr lang="en-US" smtClean="0"/>
-              <a:t>1/27/13</a:t>
+              <a:t>10/20/2026</a:t>
             </a:fld>
             <a:endParaRPr lang="en-US"/>
           </a:p>
@@ -2093,10 +2093,9 @@
           </a:lstStyle>
           <a:p>
             <a:r>
-              <a:rPr lang="en-US" smtClean="0"/>
+              <a:rPr lang="en-US"/>
               <a:t>Click to edit Master title style</a:t>
             </a:r>
-            <a:endParaRPr lang="en-US"/>
           </a:p>
         </p:txBody>
       </p:sp>
@@ -2150,38 +2149,37 @@
           <a:p>
             <a:pPr lvl="0"/>
             <a:r>
-              <a:rPr lang="en-US" smtClean="0"/>
+              <a:rPr lang="en-US"/>
               <a:t>Click to edit Master text styles</a:t>
             </a:r>
           </a:p>
           <a:p>
             <a:pPr lvl="1"/>
             <a:r>
-              <a:rPr lang="en-US" smtClean="0"/>
+              <a:rPr lang="en-US"/>
               <a:t>Second level</a:t>
             </a:r>
           </a:p>
           <a:p>
             <a:pPr lvl="2"/>
             <a:r>
-              <a:rPr lang="en-US" smtClean="0"/>
+              <a:rPr lang="en-US"/>
               <a:t>Third level</a:t>
             </a:r>
           </a:p>
           <a:p>
             <a:pPr lvl="3"/>
             <a:r>
-              <a:rPr lang="en-US" smtClean="0"/>
+              <a:rPr lang="en-US"/>
               <a:t>Fourth level</a:t>
             </a:r>
           </a:p>
           <a:p>
             <a:pPr lvl="4"/>
             <a:r>
-              <a:rPr lang="en-US" smtClean="0"/>
+              <a:rPr lang="en-US"/>
               <a:t>Fifth level</a:t>
             </a:r>
-            <a:endParaRPr lang="en-US"/>
           </a:p>
         </p:txBody>
       </p:sp>
@@ -2244,7 +2242,7 @@
           <a:p>
             <a:pPr lvl="0"/>
             <a:r>
-              <a:rPr lang="en-US" smtClean="0"/>
+              <a:rPr lang="en-US"/>
               <a:t>Click to edit Master text styles</a:t>
             </a:r>
           </a:p>
@@ -2267,7 +2265,7 @@
           <a:p>
             <a:fld id="{5BCAD085-E8A6-8845-BD4E-CB4CCA059FC4}" type="datetimeFigureOut">
               <a:rPr lang="en-US" smtClean="0"/>
-              <a:t>1/27/13</a:t>
+              <a:t>10/20/2026</a:t>
             </a:fld>
             <a:endParaRPr lang="en-US"/>
           </a:p>
@@ -2370,10 +2368,9 @@
           </a:lstStyle>
           <a:p>
             <a:r>
-              <a:rPr lang="en-US" smtClean="0"/>
+              <a:rPr lang="en-US"/>
               <a:t>Click to edit Master title style</a:t>
             </a:r>
-            <a:endParaRPr lang="en-US"/>
           </a:p>
         </p:txBody>
       </p:sp>
@@ -2497,7 +2494,7 @@
           <a:p>
             <a:pPr lvl="0"/>
             <a:r>
-              <a:rPr lang="en-US" smtClean="0"/>
+              <a:rPr lang="en-US"/>
               <a:t>Click to edit Master text styles</a:t>
             </a:r>
           </a:p>
@@ -2520,7 +2517,7 @@
           <a:p>
             <a:fld id="{5BCAD085-E8A6-8845-BD4E-CB4CCA059FC4}" type="datetimeFigureOut">
               <a:rPr lang="en-US" smtClean="0"/>
-              <a:t>1/27/13</a:t>
+              <a:t>10/20/2026</a:t>
             </a:fld>
             <a:endParaRPr lang="en-US"/>
           </a:p>
@@ -2629,10 +2626,9 @@
           <a:lstStyle/>
           <a:p>
             <a:r>
-              <a:rPr lang="en-US" smtClean="0"/>
+              <a:rPr lang="en-US"/>
               <a:t>Click to edit Master title style</a:t>
             </a:r>
-            <a:endParaRPr lang="en-US"/>
           </a:p>
         </p:txBody>
       </p:sp>
@@ -2663,38 +2659,37 @@
           <a:p>
             <a:pPr lvl="0"/>
             <a:r>
-              <a:rPr lang="en-US" smtClean="0"/>
+              <a:rPr lang="en-US"/>
               <a:t>Click to edit Master text styles</a:t>
             </a:r>
           </a:p>
           <a:p>
             <a:pPr lvl="1"/>
             <a:r>
-              <a:rPr lang="en-US" smtClean="0"/>
+              <a:rPr lang="en-US"/>
               <a:t>Second level</a:t>
             </a:r>
           </a:p>
           <a:p>
             <a:pPr lvl="2"/>
             <a:r>
-              <a:rPr lang="en-US" smtClean="0"/>
+              <a:rPr lang="en-US"/>
               <a:t>Third level</a:t>
             </a:r>
           </a:p>
           <a:p>
             <a:pPr lvl="3"/>
             <a:r>
-              <a:rPr lang="en-US" smtClean="0"/>
+              <a:rPr lang="en-US"/>
               <a:t>Fourth level</a:t>
             </a:r>
           </a:p>
           <a:p>
             <a:pPr lvl="4"/>
             <a:r>
-              <a:rPr lang="en-US" smtClean="0"/>
+              <a:rPr lang="en-US"/>
               <a:t>Fifth level</a:t>
             </a:r>
-            <a:endParaRPr lang="en-US"/>
           </a:p>
         </p:txBody>
       </p:sp>
@@ -2733,7 +2728,7 @@
           <a:p>
             <a:fld id="{5BCAD085-E8A6-8845-BD4E-CB4CCA059FC4}" type="datetimeFigureOut">
               <a:rPr lang="en-US" smtClean="0"/>
-              <a:t>1/27/13</a:t>
+              <a:t>10/20/2026</a:t>
             </a:fld>
             <a:endParaRPr lang="en-US"/>
           </a:p>
@@ -3092,7 +3087,7 @@
 </file>
 
 <file path=ppt/slides/slide1.xml><?xml version="1.0" encoding="utf-8"?>
-<p:sld xmlns:a="http://schemas.openxmlformats.org/drawingml/2006/main" xmlns:p="http://schemas.openxmlformats.org/presentationml/2006/main" xmlns:r="http://schemas.openxmlformats.org/officeDocument/2006/relationships">
+<p:sld xmlns:a="http://schemas.openxmlformats.org/drawingml/2006/main" xmlns:r="http://schemas.openxmlformats.org/officeDocument/2006/relationships" xmlns:p="http://schemas.openxmlformats.org/presentationml/2006/main">
   <p:cSld>
     <p:spTree>
       <p:nvGrpSpPr>
@@ -3100,7 +3095,14 @@
         <p:cNvGrpSpPr/>
         <p:nvPr/>
       </p:nvGrpSpPr>
-      <p:grpSpPr/>
+      <p:grpSpPr>
+        <a:xfrm>
+          <a:off x="0" y="0"/>
+          <a:ext cx="0" cy="0"/>
+          <a:chOff x="0" y="0"/>
+          <a:chExt cx="0" cy="0"/>
+        </a:xfrm>
+      </p:grpSpPr>
       <p:sp>
         <p:nvSpPr>
           <p:cNvPr id="2" name="Rectangle 1"/>
@@ -3141,6 +3143,7 @@
           <a:lstStyle/>
           <a:p>
             <a:pPr algn="ctr"/>
+            <a:endParaRPr/>
           </a:p>
         </p:txBody>
       </p:sp>
@@ -3186,6 +3189,7 @@
           <a:lstStyle/>
           <a:p>
             <a:pPr algn="ctr"/>
+            <a:endParaRPr/>
           </a:p>
         </p:txBody>
       </p:sp>
@@ -3198,7 +3202,7 @@
         <p:spPr>
           <a:xfrm>
             <a:off x="1463040" y="1143000"/>
-            <a:ext cx="9235440" cy="4572000"/>
+            <a:ext cx="9235440" cy="2816156"/>
           </a:xfrm>
           <a:prstGeom prst="rect">
             <a:avLst/>
@@ -3223,6 +3227,7 @@
               </a:defRPr>
             </a:pPr>
             <a:r>
+              <a:rPr dirty="0"/>
               <a:t>CSE355 · DATA VISUALIZATION CASE STUDY</a:t>
             </a:r>
           </a:p>
@@ -3236,6 +3241,7 @@
               </a:defRPr>
             </a:pPr>
             <a:r>
+              <a:rPr dirty="0"/>
               <a:t>Global Marine Microplastic Pollution</a:t>
             </a:r>
           </a:p>
@@ -3252,6 +3258,7 @@
               </a:defRPr>
             </a:pPr>
             <a:r>
+              <a:rPr dirty="0"/>
               <a:t>An Ethical, Bias-Aware Visualization Framework for Hotspot Detection</a:t>
             </a:r>
           </a:p>
@@ -3268,6 +3275,7 @@
               </a:defRPr>
             </a:pPr>
             <a:r>
+              <a:rPr sz="1200" dirty="0"/>
               <a:t>Student Author &amp; Submission Information:</a:t>
             </a:r>
           </a:p>
@@ -3284,6 +3292,7 @@
               </a:defRPr>
             </a:pPr>
             <a:r>
+              <a:rPr sz="1200" dirty="0"/>
               <a:t>•  Student Name: K. Ganesh Giridhar</a:t>
             </a:r>
           </a:p>
@@ -3300,6 +3309,7 @@
               </a:defRPr>
             </a:pPr>
             <a:r>
+              <a:rPr sz="1200" dirty="0"/>
               <a:t>•  Register Number: CB.SC.U4CSE24519</a:t>
             </a:r>
           </a:p>
@@ -3316,6 +3326,7 @@
               </a:defRPr>
             </a:pPr>
             <a:r>
+              <a:rPr sz="1200" dirty="0"/>
               <a:t>•  Course &amp; Department: CSE355 – Data Visualization &amp; Analytics | Dept. of Computer Science &amp; Engineering</a:t>
             </a:r>
           </a:p>
@@ -3332,6 +3343,7 @@
               </a:defRPr>
             </a:pPr>
             <a:r>
+              <a:rPr sz="1200" dirty="0"/>
               <a:t>•  Institution: School of Computing, Amrita Vishwa Vidyapeetham</a:t>
             </a:r>
           </a:p>
@@ -3348,6 +3360,7 @@
               </a:defRPr>
             </a:pPr>
             <a:r>
+              <a:rPr sz="1200" dirty="0"/>
               <a:t>•  Dataset Used: NOAA NCEI Global Marine Microplastics Database (29,076 records, 1972–2026)</a:t>
             </a:r>
           </a:p>
@@ -3398,7 +3411,7 @@
 </file>
 
 <file path=ppt/slides/slide10.xml><?xml version="1.0" encoding="utf-8"?>
-<p:sld xmlns:a="http://schemas.openxmlformats.org/drawingml/2006/main" xmlns:p="http://schemas.openxmlformats.org/presentationml/2006/main" xmlns:r="http://schemas.openxmlformats.org/officeDocument/2006/relationships">
+<p:sld xmlns:a="http://schemas.openxmlformats.org/drawingml/2006/main" xmlns:r="http://schemas.openxmlformats.org/officeDocument/2006/relationships" xmlns:p="http://schemas.openxmlformats.org/presentationml/2006/main">
   <p:cSld>
     <p:spTree>
       <p:nvGrpSpPr>
@@ -3406,7 +3419,14 @@
         <p:cNvGrpSpPr/>
         <p:nvPr/>
       </p:nvGrpSpPr>
-      <p:grpSpPr/>
+      <p:grpSpPr>
+        <a:xfrm>
+          <a:off x="0" y="0"/>
+          <a:ext cx="0" cy="0"/>
+          <a:chOff x="0" y="0"/>
+          <a:chExt cx="0" cy="0"/>
+        </a:xfrm>
+      </p:grpSpPr>
       <p:sp>
         <p:nvSpPr>
           <p:cNvPr id="2" name="Rectangle 1"/>
@@ -3447,6 +3467,7 @@
           <a:lstStyle/>
           <a:p>
             <a:pPr algn="ctr"/>
+            <a:endParaRPr/>
           </a:p>
         </p:txBody>
       </p:sp>
@@ -3562,6 +3583,7 @@
           <a:lstStyle/>
           <a:p>
             <a:pPr algn="ctr"/>
+            <a:endParaRPr/>
           </a:p>
         </p:txBody>
       </p:sp>
@@ -3703,6 +3725,7 @@
           <a:lstStyle/>
           <a:p>
             <a:pPr algn="ctr"/>
+            <a:endParaRPr/>
           </a:p>
         </p:txBody>
       </p:sp>
@@ -3800,6 +3823,7 @@
           <a:lstStyle/>
           <a:p>
             <a:pPr algn="ctr"/>
+            <a:endParaRPr/>
           </a:p>
         </p:txBody>
       </p:sp>
@@ -3897,6 +3921,7 @@
           <a:lstStyle/>
           <a:p>
             <a:pPr algn="ctr"/>
+            <a:endParaRPr/>
           </a:p>
         </p:txBody>
       </p:sp>
@@ -4025,7 +4050,7 @@
 </file>
 
 <file path=ppt/slides/slide11.xml><?xml version="1.0" encoding="utf-8"?>
-<p:sld xmlns:a="http://schemas.openxmlformats.org/drawingml/2006/main" xmlns:p="http://schemas.openxmlformats.org/presentationml/2006/main" xmlns:r="http://schemas.openxmlformats.org/officeDocument/2006/relationships">
+<p:sld xmlns:a="http://schemas.openxmlformats.org/drawingml/2006/main" xmlns:r="http://schemas.openxmlformats.org/officeDocument/2006/relationships" xmlns:p="http://schemas.openxmlformats.org/presentationml/2006/main">
   <p:cSld>
     <p:spTree>
       <p:nvGrpSpPr>
@@ -4033,7 +4058,14 @@
         <p:cNvGrpSpPr/>
         <p:nvPr/>
       </p:nvGrpSpPr>
-      <p:grpSpPr/>
+      <p:grpSpPr>
+        <a:xfrm>
+          <a:off x="0" y="0"/>
+          <a:ext cx="0" cy="0"/>
+          <a:chOff x="0" y="0"/>
+          <a:chExt cx="0" cy="0"/>
+        </a:xfrm>
+      </p:grpSpPr>
       <p:sp>
         <p:nvSpPr>
           <p:cNvPr id="2" name="Rectangle 1"/>
@@ -4074,6 +4106,7 @@
           <a:lstStyle/>
           <a:p>
             <a:pPr algn="ctr"/>
+            <a:endParaRPr/>
           </a:p>
         </p:txBody>
       </p:sp>
@@ -4189,6 +4222,7 @@
           <a:lstStyle/>
           <a:p>
             <a:pPr algn="ctr"/>
+            <a:endParaRPr/>
           </a:p>
         </p:txBody>
       </p:sp>
@@ -4276,7 +4310,9 @@
             <a:ext cx="5212080" cy="5120640"/>
           </a:xfrm>
           <a:prstGeom prst="roundRect">
-            <a:avLst/>
+            <a:avLst>
+              <a:gd name="adj" fmla="val 2751"/>
+            </a:avLst>
           </a:prstGeom>
           <a:solidFill>
             <a:srgbClr val="FFFFFF"/>
@@ -4306,6 +4342,7 @@
           <a:lstStyle/>
           <a:p>
             <a:pPr algn="ctr"/>
+            <a:endParaRPr/>
           </a:p>
         </p:txBody>
       </p:sp>
@@ -4340,6 +4377,7 @@
               </a:defRPr>
             </a:pPr>
             <a:r>
+              <a:rPr dirty="0"/>
               <a:t>INTENTIONALLY MISLEADING VISUALIZATION</a:t>
             </a:r>
           </a:p>
@@ -4353,18 +4391,28 @@
               </a:defRPr>
             </a:pPr>
             <a:r>
+              <a:rPr dirty="0"/>
               <a:t>• Distortion: Truncated Y-axis baseline starting at 0.200 instead of 0.0.</a:t>
             </a:r>
-            <a:br/>
-            <a:r>
+            <a:br>
+              <a:rPr dirty="0"/>
+            </a:br>
+            <a:r>
+              <a:rPr dirty="0"/>
               <a:t>• Visual Exaggeration: Makes a modest ~10% change look like an alarming 800% pollution surge!</a:t>
             </a:r>
-            <a:br/>
-            <a:r>
+            <a:br>
+              <a:rPr dirty="0"/>
+            </a:br>
+            <a:r>
+              <a:rPr dirty="0"/>
               <a:t>• Concealed Information: Hides sample sizes (n), hides wide dispersion, and conceals unit boundaries.</a:t>
             </a:r>
-            <a:br/>
-            <a:r>
+            <a:br>
+              <a:rPr dirty="0"/>
+            </a:br>
+            <a:r>
+              <a:rPr dirty="0"/>
               <a:t>• Psychological Effect: Induces unwarranted public panic and distorts environmental priorities.</a:t>
             </a:r>
           </a:p>
@@ -4406,7 +4454,9 @@
             <a:ext cx="5212080" cy="5120640"/>
           </a:xfrm>
           <a:prstGeom prst="roundRect">
-            <a:avLst/>
+            <a:avLst>
+              <a:gd name="adj" fmla="val 5707"/>
+            </a:avLst>
           </a:prstGeom>
           <a:solidFill>
             <a:srgbClr val="FFFFFF"/>
@@ -4436,6 +4486,7 @@
           <a:lstStyle/>
           <a:p>
             <a:pPr algn="ctr"/>
+            <a:endParaRPr/>
           </a:p>
         </p:txBody>
       </p:sp>
@@ -4533,7 +4584,7 @@
 </file>
 
 <file path=ppt/slides/slide12.xml><?xml version="1.0" encoding="utf-8"?>
-<p:sld xmlns:a="http://schemas.openxmlformats.org/drawingml/2006/main" xmlns:p="http://schemas.openxmlformats.org/presentationml/2006/main" xmlns:r="http://schemas.openxmlformats.org/officeDocument/2006/relationships">
+<p:sld xmlns:a="http://schemas.openxmlformats.org/drawingml/2006/main" xmlns:r="http://schemas.openxmlformats.org/officeDocument/2006/relationships" xmlns:p="http://schemas.openxmlformats.org/presentationml/2006/main">
   <p:cSld>
     <p:spTree>
       <p:nvGrpSpPr>
@@ -4541,7 +4592,14 @@
         <p:cNvGrpSpPr/>
         <p:nvPr/>
       </p:nvGrpSpPr>
-      <p:grpSpPr/>
+      <p:grpSpPr>
+        <a:xfrm>
+          <a:off x="0" y="0"/>
+          <a:ext cx="0" cy="0"/>
+          <a:chOff x="0" y="0"/>
+          <a:chExt cx="0" cy="0"/>
+        </a:xfrm>
+      </p:grpSpPr>
       <p:sp>
         <p:nvSpPr>
           <p:cNvPr id="2" name="Rectangle 1"/>
@@ -4582,6 +4640,7 @@
           <a:lstStyle/>
           <a:p>
             <a:pPr algn="ctr"/>
+            <a:endParaRPr/>
           </a:p>
         </p:txBody>
       </p:sp>
@@ -4652,6 +4711,7 @@
               </a:defRPr>
             </a:pPr>
             <a:r>
+              <a:rPr dirty="0"/>
               <a:t>Key Scientific Findings and Analytical Insights</a:t>
             </a:r>
           </a:p>
@@ -4697,6 +4757,7 @@
           <a:lstStyle/>
           <a:p>
             <a:pPr algn="ctr"/>
+            <a:endParaRPr/>
           </a:p>
         </p:txBody>
       </p:sp>
@@ -4814,6 +4875,7 @@
           <a:lstStyle/>
           <a:p>
             <a:pPr algn="ctr"/>
+            <a:endParaRPr/>
           </a:p>
         </p:txBody>
       </p:sp>
@@ -4826,7 +4888,7 @@
         <p:spPr>
           <a:xfrm>
             <a:off x="841248" y="1234440"/>
-            <a:ext cx="3163824" cy="3383280"/>
+            <a:ext cx="3163824" cy="2385268"/>
           </a:xfrm>
           <a:prstGeom prst="rect">
             <a:avLst/>
@@ -4848,6 +4910,7 @@
               </a:defRPr>
             </a:pPr>
             <a:r>
+              <a:rPr sz="1200" dirty="0"/>
               <a:t>FINDING 1: SAMPLING EFFORT BIAS DISTORTS SPATIAL PERCEPTION</a:t>
             </a:r>
           </a:p>
@@ -4864,6 +4927,7 @@
               </a:defRPr>
             </a:pPr>
             <a:r>
+              <a:rPr sz="1000" dirty="0"/>
               <a:t>Supported by V1, V2, and Power BI Page 1</a:t>
             </a:r>
           </a:p>
@@ -4880,6 +4944,7 @@
               </a:defRPr>
             </a:pPr>
             <a:r>
+              <a:rPr sz="1050" dirty="0"/>
               <a:t>• 94.2% of all historical monitoring is concentrated in the Northern Hemisphere.</a:t>
             </a:r>
           </a:p>
@@ -4896,6 +4961,7 @@
               </a:defRPr>
             </a:pPr>
             <a:r>
+              <a:rPr sz="1050" dirty="0"/>
               <a:t>• The Atlantic Ocean accounts for 66.7% of all data (19,394 samples) with a low median concentration of 0.42 pcs/m³.</a:t>
             </a:r>
           </a:p>
@@ -4912,6 +4978,7 @@
               </a:defRPr>
             </a:pPr>
             <a:r>
+              <a:rPr sz="1050" dirty="0"/>
               <a:t>• In contrast, the Pacific Ocean holds only 24.4% of records but carries over 4x higher median pollution (1.84 pcs/m³).</a:t>
             </a:r>
           </a:p>
@@ -4928,6 +4995,7 @@
               </a:defRPr>
             </a:pPr>
             <a:r>
+              <a:rPr sz="1050" dirty="0"/>
               <a:t>• Core Lesson: Observation density reflects maritime cruise traffic, NOT ecological severity.</a:t>
             </a:r>
           </a:p>
@@ -4975,6 +5043,7 @@
           <a:lstStyle/>
           <a:p>
             <a:pPr algn="ctr"/>
+            <a:endParaRPr/>
           </a:p>
         </p:txBody>
       </p:sp>
@@ -4987,7 +5056,7 @@
         <p:spPr>
           <a:xfrm>
             <a:off x="4480560" y="1234440"/>
-            <a:ext cx="3163824" cy="3383280"/>
+            <a:ext cx="3163824" cy="2551981"/>
           </a:xfrm>
           <a:prstGeom prst="rect">
             <a:avLst/>
@@ -5009,6 +5078,7 @@
               </a:defRPr>
             </a:pPr>
             <a:r>
+              <a:rPr sz="1400" dirty="0"/>
               <a:t>FINDING 2: ENVIRONMENTAL COMPARTMENTS OPERATE ON DIFFERENT SCALES</a:t>
             </a:r>
           </a:p>
@@ -5025,6 +5095,7 @@
               </a:defRPr>
             </a:pPr>
             <a:r>
+              <a:rPr sz="1050" dirty="0"/>
               <a:t>Supported by V4, V5, and Power BI Page 2</a:t>
             </a:r>
           </a:p>
@@ -5041,6 +5112,7 @@
               </a:defRPr>
             </a:pPr>
             <a:r>
+              <a:rPr sz="1100" dirty="0"/>
               <a:t>• Surface water median concentration is 0.01 pcs/m³, while beach sand median is 1,280 pcs/m³.</a:t>
             </a:r>
           </a:p>
@@ -5057,6 +5129,7 @@
               </a:defRPr>
             </a:pPr>
             <a:r>
+              <a:rPr sz="1100" dirty="0"/>
               <a:t>• Nurdle Patrol records a median of 10.0 pellets per 10-minute survey, with localized industrial spills exceeding 1,000 pellets.</a:t>
             </a:r>
           </a:p>
@@ -5073,6 +5146,7 @@
               </a:defRPr>
             </a:pPr>
             <a:r>
+              <a:rPr sz="1100" dirty="0"/>
               <a:t>• Core Lesson: The 3 measurement units are physically incommensurate. Pooling them into a single global average produces invalid, deceptive numbers.</a:t>
             </a:r>
           </a:p>
@@ -5120,6 +5194,7 @@
           <a:lstStyle/>
           <a:p>
             <a:pPr algn="ctr"/>
+            <a:endParaRPr/>
           </a:p>
         </p:txBody>
       </p:sp>
@@ -5132,7 +5207,7 @@
         <p:spPr>
           <a:xfrm>
             <a:off x="8119872" y="1234440"/>
-            <a:ext cx="3163824" cy="3383280"/>
+            <a:ext cx="3163824" cy="2336537"/>
           </a:xfrm>
           <a:prstGeom prst="rect">
             <a:avLst/>
@@ -5154,6 +5229,7 @@
               </a:defRPr>
             </a:pPr>
             <a:r>
+              <a:rPr sz="1400" dirty="0"/>
               <a:t>FINDING 3: NET MESH SIZE CREATES A 4X UNDER-COUNTING BIAS</a:t>
             </a:r>
           </a:p>
@@ -5170,6 +5246,7 @@
               </a:defRPr>
             </a:pPr>
             <a:r>
+              <a:rPr sz="1050" dirty="0"/>
               <a:t>Supported by V6, V7, and Power BI Page 3</a:t>
             </a:r>
           </a:p>
@@ -5186,6 +5263,7 @@
               </a:defRPr>
             </a:pPr>
             <a:r>
+              <a:rPr sz="1100" dirty="0"/>
               <a:t>• Standard manta and neuston nets use 333 um mesh, allowing synthetic microfibers (&lt;100 um) to pass straight through.</a:t>
             </a:r>
           </a:p>
@@ -5202,6 +5280,7 @@
               </a:defRPr>
             </a:pPr>
             <a:r>
+              <a:rPr sz="1100" dirty="0"/>
               <a:t>• Fine filtration samplers (&lt;100 um) capture over 4.2x more microplastics per m³ than standard trawls.</a:t>
             </a:r>
           </a:p>
@@ -5218,6 +5297,7 @@
               </a:defRPr>
             </a:pPr>
             <a:r>
+              <a:rPr sz="1100" dirty="0"/>
               <a:t>• Core Lesson: The vast majority of historical ocean data systematically under-counts total marine plastic burden.</a:t>
             </a:r>
           </a:p>
@@ -5265,6 +5345,7 @@
           <a:lstStyle/>
           <a:p>
             <a:pPr algn="ctr"/>
+            <a:endParaRPr/>
           </a:p>
         </p:txBody>
       </p:sp>
@@ -5359,6 +5440,7 @@
           <a:lstStyle/>
           <a:p>
             <a:pPr algn="ctr"/>
+            <a:endParaRPr/>
           </a:p>
         </p:txBody>
       </p:sp>
@@ -5453,6 +5535,7 @@
           <a:lstStyle/>
           <a:p>
             <a:pPr algn="ctr"/>
+            <a:endParaRPr/>
           </a:p>
         </p:txBody>
       </p:sp>
@@ -5514,7 +5597,7 @@
 </file>
 
 <file path=ppt/slides/slide13.xml><?xml version="1.0" encoding="utf-8"?>
-<p:sld xmlns:a="http://schemas.openxmlformats.org/drawingml/2006/main" xmlns:p="http://schemas.openxmlformats.org/presentationml/2006/main" xmlns:r="http://schemas.openxmlformats.org/officeDocument/2006/relationships">
+<p:sld xmlns:a="http://schemas.openxmlformats.org/drawingml/2006/main" xmlns:r="http://schemas.openxmlformats.org/officeDocument/2006/relationships" xmlns:p="http://schemas.openxmlformats.org/presentationml/2006/main">
   <p:cSld>
     <p:spTree>
       <p:nvGrpSpPr>
@@ -5522,7 +5605,14 @@
         <p:cNvGrpSpPr/>
         <p:nvPr/>
       </p:nvGrpSpPr>
-      <p:grpSpPr/>
+      <p:grpSpPr>
+        <a:xfrm>
+          <a:off x="0" y="0"/>
+          <a:ext cx="0" cy="0"/>
+          <a:chOff x="0" y="0"/>
+          <a:chExt cx="0" cy="0"/>
+        </a:xfrm>
+      </p:grpSpPr>
       <p:sp>
         <p:nvSpPr>
           <p:cNvPr id="2" name="Rectangle 1"/>
@@ -5563,6 +5653,7 @@
           <a:lstStyle/>
           <a:p>
             <a:pPr algn="ctr"/>
+            <a:endParaRPr/>
           </a:p>
         </p:txBody>
       </p:sp>
@@ -5678,6 +5769,7 @@
           <a:lstStyle/>
           <a:p>
             <a:pPr algn="ctr"/>
+            <a:endParaRPr/>
           </a:p>
         </p:txBody>
       </p:sp>
@@ -5795,6 +5887,7 @@
           <a:lstStyle/>
           <a:p>
             <a:pPr algn="ctr"/>
+            <a:endParaRPr/>
           </a:p>
         </p:txBody>
       </p:sp>
@@ -5807,7 +5900,7 @@
         <p:spPr>
           <a:xfrm>
             <a:off x="868680" y="1216152"/>
-            <a:ext cx="10424160" cy="1453896"/>
+            <a:ext cx="10424160" cy="1290097"/>
           </a:xfrm>
           <a:prstGeom prst="rect">
             <a:avLst/>
@@ -5832,6 +5925,7 @@
               </a:defRPr>
             </a:pPr>
             <a:r>
+              <a:rPr sz="1200" dirty="0"/>
               <a:t>STRATEGIC POLICY RECOMMENDATIONS</a:t>
             </a:r>
           </a:p>
@@ -5848,6 +5942,7 @@
               </a:defRPr>
             </a:pPr>
             <a:r>
+              <a:rPr sz="1000" dirty="0"/>
               <a:t>1. Mandatory IMO Classification of Resin Pellets:</a:t>
             </a:r>
           </a:p>
@@ -5864,6 +5959,7 @@
               </a:defRPr>
             </a:pPr>
             <a:r>
+              <a:rPr sz="1000" dirty="0"/>
               <a:t>   Classify pre-production plastic pellets (nurdles) as Hazardous Cargo under the IMDG code, requiring secure below-deck container stowage.</a:t>
             </a:r>
           </a:p>
@@ -5880,6 +5976,7 @@
               </a:defRPr>
             </a:pPr>
             <a:r>
+              <a:rPr sz="1000" dirty="0"/>
               <a:t>2. Standardize Dual-Mesh Sampling (INC-5 Treaty):</a:t>
             </a:r>
           </a:p>
@@ -5896,6 +5993,7 @@
               </a:defRPr>
             </a:pPr>
             <a:r>
+              <a:rPr sz="1000" dirty="0"/>
               <a:t>   Mandate a unified protocol combining 50 um fine filtration (for microfibers) and 333 um manta trawls across all international monitoring cruises.</a:t>
             </a:r>
           </a:p>
@@ -5912,6 +6010,7 @@
               </a:defRPr>
             </a:pPr>
             <a:r>
+              <a:rPr sz="1000" dirty="0"/>
               <a:t>3. Expand Southern Hemisphere Sensor Coverage:</a:t>
             </a:r>
           </a:p>
@@ -5928,7 +6027,16 @@
               </a:defRPr>
             </a:pPr>
             <a:r>
-              <a:t>   Fund and deploy autonomous microplastic optical sensors on the global Argo Buoy array in the Indian and Southern Ocean data blindspots.</a:t>
+              <a:rPr sz="1000" dirty="0"/>
+              <a:t>   Fund and deploy autonomous microplastic optical sensors on the global Argo Buoy array in the Indian and Southern Ocean data </a:t>
+            </a:r>
+            <a:r>
+              <a:rPr sz="1000" dirty="0" err="1"/>
+              <a:t>blindspots</a:t>
+            </a:r>
+            <a:r>
+              <a:rPr sz="1000" dirty="0"/>
+              <a:t>.</a:t>
             </a:r>
           </a:p>
         </p:txBody>
@@ -5975,6 +6083,7 @@
           <a:lstStyle/>
           <a:p>
             <a:pPr algn="ctr"/>
+            <a:endParaRPr/>
           </a:p>
         </p:txBody>
       </p:sp>
@@ -5987,7 +6096,7 @@
         <p:spPr>
           <a:xfrm>
             <a:off x="868680" y="2935224"/>
-            <a:ext cx="10424160" cy="1453896"/>
+            <a:ext cx="10424160" cy="1005403"/>
           </a:xfrm>
           <a:prstGeom prst="rect">
             <a:avLst/>
@@ -6012,6 +6121,7 @@
               </a:defRPr>
             </a:pPr>
             <a:r>
+              <a:rPr sz="1400" dirty="0"/>
               <a:t>MAIN CONCLUSION &amp; ANSWER TO PROBLEM STATEMENT</a:t>
             </a:r>
           </a:p>
@@ -6028,6 +6138,7 @@
               </a:defRPr>
             </a:pPr>
             <a:r>
+              <a:rPr sz="1050" dirty="0"/>
               <a:t>• Responsible data visualization successfully decouples research effort from ecological reality.</a:t>
             </a:r>
           </a:p>
@@ -6044,6 +6155,7 @@
               </a:defRPr>
             </a:pPr>
             <a:r>
+              <a:rPr sz="1050" dirty="0"/>
               <a:t>• When data is partitioned by setting and normalized for sampling density, true contamination hot spots shift from heavily-monitored tourist coasts to pelagic convergence gyres (Pacific) and industrial estuaries.</a:t>
             </a:r>
           </a:p>
@@ -6060,6 +6172,7 @@
               </a:defRPr>
             </a:pPr>
             <a:r>
+              <a:rPr sz="1050" dirty="0"/>
               <a:t>• Ethical visualization protects public trust and ensures finite environmental cleanup capital targets genuine ecological emergencies.</a:t>
             </a:r>
           </a:p>
@@ -6107,6 +6220,7 @@
           <a:lstStyle/>
           <a:p>
             <a:pPr algn="ctr"/>
+            <a:endParaRPr/>
           </a:p>
         </p:txBody>
       </p:sp>
@@ -6119,7 +6233,7 @@
         <p:spPr>
           <a:xfrm>
             <a:off x="868680" y="4654296"/>
-            <a:ext cx="10424160" cy="1453896"/>
+            <a:ext cx="10424160" cy="669414"/>
           </a:xfrm>
           <a:prstGeom prst="rect">
             <a:avLst/>
@@ -6144,6 +6258,7 @@
               </a:defRPr>
             </a:pPr>
             <a:r>
+              <a:rPr sz="1400" dirty="0"/>
               <a:t>STUDY LIMITATIONS &amp; FUTURE WORK</a:t>
             </a:r>
           </a:p>
@@ -6160,6 +6275,7 @@
               </a:defRPr>
             </a:pPr>
             <a:r>
+              <a:rPr sz="1050" dirty="0"/>
               <a:t>• Data Limitations: Historical records lack automated spectroscopic polymer identification (FTIR/Raman), and citizen science survey frequency is variable.</a:t>
             </a:r>
           </a:p>
@@ -6176,6 +6292,7 @@
               </a:defRPr>
             </a:pPr>
             <a:r>
+              <a:rPr sz="1050" dirty="0"/>
               <a:t>• Future Improvement: Integrating satellite-derived ocean surface circulation models (HYCOM / Copernicus) with real-time autonomous buoys to predict microplastic drift trajectories.</a:t>
             </a:r>
           </a:p>
@@ -6190,7 +6307,7 @@
 </file>
 
 <file path=ppt/slides/slide14.xml><?xml version="1.0" encoding="utf-8"?>
-<p:sld xmlns:a="http://schemas.openxmlformats.org/drawingml/2006/main" xmlns:p="http://schemas.openxmlformats.org/presentationml/2006/main" xmlns:r="http://schemas.openxmlformats.org/officeDocument/2006/relationships">
+<p:sld xmlns:a="http://schemas.openxmlformats.org/drawingml/2006/main" xmlns:r="http://schemas.openxmlformats.org/officeDocument/2006/relationships" xmlns:p="http://schemas.openxmlformats.org/presentationml/2006/main">
   <p:cSld>
     <p:spTree>
       <p:nvGrpSpPr>
@@ -6198,7 +6315,14 @@
         <p:cNvGrpSpPr/>
         <p:nvPr/>
       </p:nvGrpSpPr>
-      <p:grpSpPr/>
+      <p:grpSpPr>
+        <a:xfrm>
+          <a:off x="0" y="0"/>
+          <a:ext cx="0" cy="0"/>
+          <a:chOff x="0" y="0"/>
+          <a:chExt cx="0" cy="0"/>
+        </a:xfrm>
+      </p:grpSpPr>
       <p:sp>
         <p:nvSpPr>
           <p:cNvPr id="2" name="Rectangle 1"/>
@@ -6239,6 +6363,7 @@
           <a:lstStyle/>
           <a:p>
             <a:pPr algn="ctr"/>
+            <a:endParaRPr/>
           </a:p>
         </p:txBody>
       </p:sp>
@@ -6354,6 +6479,7 @@
           <a:lstStyle/>
           <a:p>
             <a:pPr algn="ctr"/>
+            <a:endParaRPr/>
           </a:p>
         </p:txBody>
       </p:sp>
@@ -6441,7 +6567,9 @@
             <a:ext cx="6217920" cy="5120640"/>
           </a:xfrm>
           <a:prstGeom prst="roundRect">
-            <a:avLst/>
+            <a:avLst>
+              <a:gd name="adj" fmla="val 9401"/>
+            </a:avLst>
           </a:prstGeom>
           <a:solidFill>
             <a:srgbClr val="EEF5F8"/>
@@ -6471,6 +6599,7 @@
           <a:lstStyle/>
           <a:p>
             <a:pPr algn="ctr"/>
+            <a:endParaRPr/>
           </a:p>
         </p:txBody>
       </p:sp>
@@ -6483,7 +6612,7 @@
         <p:spPr>
           <a:xfrm>
             <a:off x="868680" y="1234440"/>
-            <a:ext cx="5943600" cy="4846320"/>
+            <a:ext cx="5943600" cy="4955203"/>
           </a:xfrm>
           <a:prstGeom prst="rect">
             <a:avLst/>
@@ -6508,6 +6637,7 @@
               </a:defRPr>
             </a:pPr>
             <a:r>
+              <a:rPr sz="1200" dirty="0"/>
               <a:t>LIVE DASHBOARD DEMONSTRATION WORKFLOW</a:t>
             </a:r>
           </a:p>
@@ -6524,16 +6654,46 @@
               </a:defRPr>
             </a:pPr>
             <a:r>
-              <a:t>Step 1: Open Power BI Desktop (.pbip) Project: </a:t>
-            </a:r>
-            <a:r>
-              <a:rPr b="0">
+              <a:rPr sz="1200" dirty="0"/>
+              <a:t>Step 1: Open Power BI Desktop (.</a:t>
+            </a:r>
+            <a:r>
+              <a:rPr sz="1200" dirty="0" err="1"/>
+              <a:t>pbip</a:t>
+            </a:r>
+            <a:r>
+              <a:rPr sz="1200" dirty="0"/>
+              <a:t>) Project: </a:t>
+            </a:r>
+            <a:r>
+              <a:rPr sz="1200" b="0" dirty="0">
                 <a:solidFill>
                   <a:srgbClr val="1E293B"/>
                 </a:solidFill>
               </a:rPr>
-              <a:t>Launch 'Marine_Microplastics_Executive.pbip' or double-click 'power_bi_interactive_dashboard.html'.</a:t>
-            </a:r>
+              <a:t>Launch '</a:t>
+            </a:r>
+            <a:r>
+              <a:rPr sz="1200" b="0" dirty="0" err="1">
+                <a:solidFill>
+                  <a:srgbClr val="1E293B"/>
+                </a:solidFill>
+              </a:rPr>
+              <a:t>Marine_Microplastics_Executive.pbip</a:t>
+            </a:r>
+            <a:r>
+              <a:rPr sz="1200" b="0" dirty="0">
+                <a:solidFill>
+                  <a:srgbClr val="1E293B"/>
+                </a:solidFill>
+              </a:rPr>
+              <a:t>' or double-click 'power_bi_interactive_dashboard.html'.</a:t>
+            </a:r>
+            <a:endParaRPr lang="en-US" sz="1200" b="0" dirty="0">
+              <a:solidFill>
+                <a:srgbClr val="1E293B"/>
+              </a:solidFill>
+            </a:endParaRPr>
           </a:p>
           <a:p>
             <a:pPr>
@@ -6547,17 +6707,41 @@
                 <a:latin typeface="Calibri"/>
               </a:defRPr>
             </a:pPr>
-            <a:r>
+            <a:endParaRPr sz="1200" b="0" dirty="0">
+              <a:solidFill>
+                <a:srgbClr val="1E293B"/>
+              </a:solidFill>
+            </a:endParaRPr>
+          </a:p>
+          <a:p>
+            <a:pPr>
+              <a:spcAft>
+                <a:spcPts val="400"/>
+              </a:spcAft>
+              <a:defRPr sz="950" b="1">
+                <a:solidFill>
+                  <a:srgbClr val="147483"/>
+                </a:solidFill>
+                <a:latin typeface="Calibri"/>
+              </a:defRPr>
+            </a:pPr>
+            <a:r>
+              <a:rPr sz="1200" dirty="0"/>
               <a:t>Step 2: Demonstrate Marine Setting Unit Isolation: </a:t>
             </a:r>
             <a:r>
-              <a:rPr b="0">
+              <a:rPr sz="1200" b="0" dirty="0">
                 <a:solidFill>
                   <a:srgbClr val="1E293B"/>
                 </a:solidFill>
               </a:rPr>
               <a:t>Select 'Marine Setting = Ocean water' on Page 1. Show that all visuals instantly filter to pieces/m³ exclusively with zero cross-unit contamination.</a:t>
             </a:r>
+            <a:endParaRPr lang="en-US" sz="1200" b="0" dirty="0">
+              <a:solidFill>
+                <a:srgbClr val="1E293B"/>
+              </a:solidFill>
+            </a:endParaRPr>
           </a:p>
           <a:p>
             <a:pPr>
@@ -6571,17 +6755,57 @@
                 <a:latin typeface="Calibri"/>
               </a:defRPr>
             </a:pPr>
-            <a:r>
+            <a:endParaRPr sz="1200" b="0" dirty="0">
+              <a:solidFill>
+                <a:srgbClr val="1E293B"/>
+              </a:solidFill>
+            </a:endParaRPr>
+          </a:p>
+          <a:p>
+            <a:pPr>
+              <a:spcAft>
+                <a:spcPts val="400"/>
+              </a:spcAft>
+              <a:defRPr sz="950" b="1">
+                <a:solidFill>
+                  <a:srgbClr val="147483"/>
+                </a:solidFill>
+                <a:latin typeface="Calibri"/>
+              </a:defRPr>
+            </a:pPr>
+            <a:r>
+              <a:rPr sz="1200" dirty="0"/>
               <a:t>Step 3: Expose Northern Hemisphere Sampling Bias: </a:t>
             </a:r>
             <a:r>
-              <a:rPr b="0">
+              <a:rPr sz="1200" b="0" dirty="0">
                 <a:solidFill>
                   <a:srgbClr val="1E293B"/>
                 </a:solidFill>
               </a:rPr>
-              <a:t>Demonstrate that 94.2% of records cluster in the North Atlantic and Gulf of Mexico, while the Indian Ocean (2.7%) and Southern Ocean (0.1%) remain blindspots.</a:t>
-            </a:r>
+              <a:t>Demonstrate that 94.2% of records cluster in the North Atlantic and Gulf of Mexico, while the Indian Ocean (2.7%) and Southern Ocean (0.1%) remain </a:t>
+            </a:r>
+            <a:r>
+              <a:rPr sz="1200" b="0" dirty="0" err="1">
+                <a:solidFill>
+                  <a:srgbClr val="1E293B"/>
+                </a:solidFill>
+              </a:rPr>
+              <a:t>blindspots</a:t>
+            </a:r>
+            <a:r>
+              <a:rPr sz="1200" b="0" dirty="0">
+                <a:solidFill>
+                  <a:srgbClr val="1E293B"/>
+                </a:solidFill>
+              </a:rPr>
+              <a:t>.</a:t>
+            </a:r>
+            <a:endParaRPr lang="en-US" sz="1200" b="0" dirty="0">
+              <a:solidFill>
+                <a:srgbClr val="1E293B"/>
+              </a:solidFill>
+            </a:endParaRPr>
           </a:p>
           <a:p>
             <a:pPr>
@@ -6595,17 +6819,41 @@
                 <a:latin typeface="Calibri"/>
               </a:defRPr>
             </a:pPr>
-            <a:r>
+            <a:endParaRPr sz="1200" b="0" dirty="0">
+              <a:solidFill>
+                <a:srgbClr val="1E293B"/>
+              </a:solidFill>
+            </a:endParaRPr>
+          </a:p>
+          <a:p>
+            <a:pPr>
+              <a:spcAft>
+                <a:spcPts val="400"/>
+              </a:spcAft>
+              <a:defRPr sz="950" b="1">
+                <a:solidFill>
+                  <a:srgbClr val="147483"/>
+                </a:solidFill>
+                <a:latin typeface="Calibri"/>
+              </a:defRPr>
+            </a:pPr>
+            <a:r>
+              <a:rPr sz="1200" dirty="0"/>
               <a:t>Step 4: Explore Basin &amp; Severity Deep-Dive: </a:t>
             </a:r>
             <a:r>
-              <a:rPr b="0">
+              <a:rPr sz="1200" b="0" dirty="0">
                 <a:solidFill>
                   <a:srgbClr val="1E293B"/>
                 </a:solidFill>
               </a:rPr>
               <a:t>Navigate to Page 2. Filter to 'Pacific Ocean' to prove that median concentration (1.84 pcs/m³) is over 4x higher than the over-sampled Atlantic Ocean.</a:t>
             </a:r>
+            <a:endParaRPr lang="en-US" sz="1200" b="0" dirty="0">
+              <a:solidFill>
+                <a:srgbClr val="1E293B"/>
+              </a:solidFill>
+            </a:endParaRPr>
           </a:p>
           <a:p>
             <a:pPr>
@@ -6619,17 +6867,41 @@
                 <a:latin typeface="Calibri"/>
               </a:defRPr>
             </a:pPr>
-            <a:r>
+            <a:endParaRPr sz="1200" b="0" dirty="0">
+              <a:solidFill>
+                <a:srgbClr val="1E293B"/>
+              </a:solidFill>
+            </a:endParaRPr>
+          </a:p>
+          <a:p>
+            <a:pPr>
+              <a:spcAft>
+                <a:spcPts val="400"/>
+              </a:spcAft>
+              <a:defRPr sz="950" b="1">
+                <a:solidFill>
+                  <a:srgbClr val="147483"/>
+                </a:solidFill>
+                <a:latin typeface="Calibri"/>
+              </a:defRPr>
+            </a:pPr>
+            <a:r>
+              <a:rPr sz="1200" dirty="0"/>
               <a:t>Step 5: Present the Forensic Ethical Redesign: </a:t>
             </a:r>
             <a:r>
-              <a:rPr b="0">
+              <a:rPr sz="1200" b="0" dirty="0">
                 <a:solidFill>
                   <a:srgbClr val="1E293B"/>
                 </a:solidFill>
               </a:rPr>
               <a:t>Navigate to Page 3. Compare the truncated Y-axis chart (starting at 0.200) with the zero-baseline redesign to show how easily visual perception is manipulated.</a:t>
             </a:r>
+            <a:endParaRPr lang="en-US" sz="1200" b="0" dirty="0">
+              <a:solidFill>
+                <a:srgbClr val="1E293B"/>
+              </a:solidFill>
+            </a:endParaRPr>
           </a:p>
           <a:p>
             <a:pPr>
@@ -6643,11 +6915,30 @@
                 <a:latin typeface="Calibri"/>
               </a:defRPr>
             </a:pPr>
-            <a:r>
+            <a:endParaRPr sz="1200" b="0" dirty="0">
+              <a:solidFill>
+                <a:srgbClr val="1E293B"/>
+              </a:solidFill>
+            </a:endParaRPr>
+          </a:p>
+          <a:p>
+            <a:pPr>
+              <a:spcAft>
+                <a:spcPts val="400"/>
+              </a:spcAft>
+              <a:defRPr sz="950" b="1">
+                <a:solidFill>
+                  <a:srgbClr val="147483"/>
+                </a:solidFill>
+                <a:latin typeface="Calibri"/>
+              </a:defRPr>
+            </a:pPr>
+            <a:r>
+              <a:rPr sz="1200" dirty="0"/>
               <a:t>Step 6: Defend Rigorous Data Decisions: </a:t>
             </a:r>
             <a:r>
-              <a:rPr b="0">
+              <a:rPr sz="1200" b="0" dirty="0">
                 <a:solidFill>
                   <a:srgbClr val="1E293B"/>
                 </a:solidFill>
@@ -6669,7 +6960,9 @@
             <a:ext cx="4297680" cy="5120640"/>
           </a:xfrm>
           <a:prstGeom prst="roundRect">
-            <a:avLst/>
+            <a:avLst>
+              <a:gd name="adj" fmla="val 8156"/>
+            </a:avLst>
           </a:prstGeom>
           <a:solidFill>
             <a:srgbClr val="FFFFFF"/>
@@ -6699,6 +6992,7 @@
           <a:lstStyle/>
           <a:p>
             <a:pPr algn="ctr"/>
+            <a:endParaRPr/>
           </a:p>
         </p:txBody>
       </p:sp>
@@ -6711,7 +7005,7 @@
         <p:spPr>
           <a:xfrm>
             <a:off x="7269480" y="1234440"/>
-            <a:ext cx="4023360" cy="4846320"/>
+            <a:ext cx="4023360" cy="3888244"/>
           </a:xfrm>
           <a:prstGeom prst="rect">
             <a:avLst/>
@@ -6736,6 +7030,7 @@
               </a:defRPr>
             </a:pPr>
             <a:r>
+              <a:rPr sz="1000" dirty="0"/>
               <a:t>CORE VIVA DEFENSE PREPARATION</a:t>
             </a:r>
           </a:p>
@@ -6752,17 +7047,25 @@
               </a:defRPr>
             </a:pPr>
             <a:r>
+              <a:rPr sz="1000" dirty="0"/>
               <a:t>Q: Why did you not convert pieces/10 min into pieces/m³?</a:t>
             </a:r>
-            <a:br/>
-            <a:r>
-              <a:rPr b="0">
+            <a:br>
+              <a:rPr sz="1000" dirty="0"/>
+            </a:br>
+            <a:r>
+              <a:rPr sz="1000" b="0" dirty="0">
                 <a:solidFill>
                   <a:srgbClr val="1E293B"/>
                 </a:solidFill>
               </a:rPr>
               <a:t>A: It is physically impossible without knowing tow velocity, water depth, and wave dynamics. Nurdle Patrol is a timed shoreline search; pooling it with volumetric water tows would produce scientifically invalid pseudo-data.</a:t>
             </a:r>
+            <a:endParaRPr lang="en-US" sz="1000" b="0" dirty="0">
+              <a:solidFill>
+                <a:srgbClr val="1E293B"/>
+              </a:solidFill>
+            </a:endParaRPr>
           </a:p>
           <a:p>
             <a:pPr>
@@ -6776,18 +7079,44 @@
                 <a:latin typeface="Calibri"/>
               </a:defRPr>
             </a:pPr>
-            <a:r>
+            <a:endParaRPr sz="1000" b="0" dirty="0">
+              <a:solidFill>
+                <a:srgbClr val="1E293B"/>
+              </a:solidFill>
+            </a:endParaRPr>
+          </a:p>
+          <a:p>
+            <a:pPr>
+              <a:spcAft>
+                <a:spcPts val="600"/>
+              </a:spcAft>
+              <a:defRPr sz="950" b="1">
+                <a:solidFill>
+                  <a:srgbClr val="147483"/>
+                </a:solidFill>
+                <a:latin typeface="Calibri"/>
+              </a:defRPr>
+            </a:pPr>
+            <a:r>
+              <a:rPr sz="1000" dirty="0"/>
               <a:t>Q: Why use Median and IQR instead of Mean and Std Dev?</a:t>
             </a:r>
-            <a:br/>
-            <a:r>
-              <a:rPr b="0">
+            <a:br>
+              <a:rPr sz="1000" dirty="0"/>
+            </a:br>
+            <a:r>
+              <a:rPr sz="1000" b="0" dirty="0">
                 <a:solidFill>
                   <a:srgbClr val="1E293B"/>
                 </a:solidFill>
               </a:rPr>
               <a:t>A: Environmental microplastic counts span 6 orders of magnitude (0.001 to &gt;10,000) with high zero-rates. The arithmetic mean is heavily skewed by a few extreme outliers, whereas the median represents true typical exposure.</a:t>
             </a:r>
+            <a:endParaRPr lang="en-US" sz="1000" b="0" dirty="0">
+              <a:solidFill>
+                <a:srgbClr val="1E293B"/>
+              </a:solidFill>
+            </a:endParaRPr>
           </a:p>
           <a:p>
             <a:pPr>
@@ -6801,18 +7130,44 @@
                 <a:latin typeface="Calibri"/>
               </a:defRPr>
             </a:pPr>
-            <a:r>
+            <a:endParaRPr sz="1000" b="0" dirty="0">
+              <a:solidFill>
+                <a:srgbClr val="1E293B"/>
+              </a:solidFill>
+            </a:endParaRPr>
+          </a:p>
+          <a:p>
+            <a:pPr>
+              <a:spcAft>
+                <a:spcPts val="600"/>
+              </a:spcAft>
+              <a:defRPr sz="950" b="1">
+                <a:solidFill>
+                  <a:srgbClr val="147483"/>
+                </a:solidFill>
+                <a:latin typeface="Calibri"/>
+              </a:defRPr>
+            </a:pPr>
+            <a:r>
+              <a:rPr sz="1000" dirty="0"/>
               <a:t>Q: How does Power BI ensure data integrity across units?</a:t>
             </a:r>
-            <a:br/>
-            <a:r>
-              <a:rPr b="0">
+            <a:br>
+              <a:rPr sz="1000" dirty="0"/>
+            </a:br>
+            <a:r>
+              <a:rPr sz="1000" b="0" dirty="0">
                 <a:solidFill>
                   <a:srgbClr val="1E293B"/>
                 </a:solidFill>
               </a:rPr>
               <a:t>A: Through a certified Star Schema where DAX measures apply strict context filtering and DAX switches enforce unit gating automatically.</a:t>
             </a:r>
+            <a:endParaRPr lang="en-US" sz="1000" b="0" dirty="0">
+              <a:solidFill>
+                <a:srgbClr val="1E293B"/>
+              </a:solidFill>
+            </a:endParaRPr>
           </a:p>
           <a:p>
             <a:pPr>
@@ -6826,12 +7181,33 @@
                 <a:latin typeface="Calibri"/>
               </a:defRPr>
             </a:pPr>
-            <a:r>
+            <a:endParaRPr sz="1000" b="0" dirty="0">
+              <a:solidFill>
+                <a:srgbClr val="1E293B"/>
+              </a:solidFill>
+            </a:endParaRPr>
+          </a:p>
+          <a:p>
+            <a:pPr>
+              <a:spcAft>
+                <a:spcPts val="600"/>
+              </a:spcAft>
+              <a:defRPr sz="950" b="1">
+                <a:solidFill>
+                  <a:srgbClr val="147483"/>
+                </a:solidFill>
+                <a:latin typeface="Calibri"/>
+              </a:defRPr>
+            </a:pPr>
+            <a:r>
+              <a:rPr sz="1000" dirty="0"/>
               <a:t>Q: What is the single most actionable finding?</a:t>
             </a:r>
-            <a:br/>
-            <a:r>
-              <a:rPr b="0">
+            <a:br>
+              <a:rPr sz="1000" dirty="0"/>
+            </a:br>
+            <a:r>
+              <a:rPr sz="1000" b="0" dirty="0">
                 <a:solidFill>
                   <a:srgbClr val="1E293B"/>
                 </a:solidFill>
@@ -6850,7 +7226,7 @@
 </file>
 
 <file path=ppt/slides/slide2.xml><?xml version="1.0" encoding="utf-8"?>
-<p:sld xmlns:a="http://schemas.openxmlformats.org/drawingml/2006/main" xmlns:p="http://schemas.openxmlformats.org/presentationml/2006/main" xmlns:r="http://schemas.openxmlformats.org/officeDocument/2006/relationships">
+<p:sld xmlns:a="http://schemas.openxmlformats.org/drawingml/2006/main" xmlns:r="http://schemas.openxmlformats.org/officeDocument/2006/relationships" xmlns:p="http://schemas.openxmlformats.org/presentationml/2006/main">
   <p:cSld>
     <p:spTree>
       <p:nvGrpSpPr>
@@ -6858,7 +7234,14 @@
         <p:cNvGrpSpPr/>
         <p:nvPr/>
       </p:nvGrpSpPr>
-      <p:grpSpPr/>
+      <p:grpSpPr>
+        <a:xfrm>
+          <a:off x="0" y="0"/>
+          <a:ext cx="0" cy="0"/>
+          <a:chOff x="0" y="0"/>
+          <a:chExt cx="0" cy="0"/>
+        </a:xfrm>
+      </p:grpSpPr>
       <p:sp>
         <p:nvSpPr>
           <p:cNvPr id="2" name="Rectangle 1"/>
@@ -6899,6 +7282,7 @@
           <a:lstStyle/>
           <a:p>
             <a:pPr algn="ctr"/>
+            <a:endParaRPr/>
           </a:p>
         </p:txBody>
       </p:sp>
@@ -7014,6 +7398,7 @@
           <a:lstStyle/>
           <a:p>
             <a:pPr algn="ctr"/>
+            <a:endParaRPr/>
           </a:p>
         </p:txBody>
       </p:sp>
@@ -7131,6 +7516,7 @@
           <a:lstStyle/>
           <a:p>
             <a:pPr algn="ctr"/>
+            <a:endParaRPr/>
           </a:p>
         </p:txBody>
       </p:sp>
@@ -7143,7 +7529,7 @@
         <p:spPr>
           <a:xfrm>
             <a:off x="868680" y="1252728"/>
-            <a:ext cx="3108960" cy="4901184"/>
+            <a:ext cx="3108960" cy="2959785"/>
           </a:xfrm>
           <a:prstGeom prst="rect">
             <a:avLst/>
@@ -7168,6 +7554,7 @@
               </a:defRPr>
             </a:pPr>
             <a:r>
+              <a:rPr sz="1200" dirty="0"/>
               <a:t>PROBLEM CONTEXT</a:t>
             </a:r>
           </a:p>
@@ -7184,14 +7571,29 @@
               </a:defRPr>
             </a:pPr>
             <a:r>
-              <a:t>• &gt;11 million metric tonnes of plastics enter global oceans every year, breaking into microplastics (&lt;5 mm).</a:t>
-            </a:r>
-            <a:br/>
-            <a:r>
+              <a:rPr sz="1200" dirty="0"/>
+              <a:t>• &gt;11 million metric </a:t>
+            </a:r>
+            <a:r>
+              <a:rPr sz="1200" dirty="0" err="1"/>
+              <a:t>tonnes</a:t>
+            </a:r>
+            <a:r>
+              <a:rPr sz="1200" dirty="0"/>
+              <a:t> of plastics enter global oceans every year, breaking into microplastics (&lt;5 mm).</a:t>
+            </a:r>
+            <a:br>
+              <a:rPr sz="1200" dirty="0"/>
+            </a:br>
+            <a:r>
+              <a:rPr sz="1200" dirty="0"/>
               <a:t>• Particles adsorb toxic pollutants and contaminate marine food webs.</a:t>
             </a:r>
-            <a:br/>
-            <a:r>
+            <a:br>
+              <a:rPr sz="1200" dirty="0"/>
+            </a:br>
+            <a:r>
+              <a:rPr sz="1200" dirty="0"/>
               <a:t>• Critical Issue: Data is collected across 4 different settings with 3 incompatible measurement units.</a:t>
             </a:r>
           </a:p>
@@ -7208,6 +7610,7 @@
               </a:defRPr>
             </a:pPr>
             <a:r>
+              <a:rPr sz="1200" dirty="0"/>
               <a:t>PROBLEM STATEMENT</a:t>
             </a:r>
           </a:p>
@@ -7221,6 +7624,7 @@
               </a:defRPr>
             </a:pPr>
             <a:r>
+              <a:rPr sz="1200" dirty="0"/>
               <a:t>"How can 29,000+ global microplastic records across 4 marine settings and 3 incompatible units be visualized without confusing research effort with true pollution hotspots?"</a:t>
             </a:r>
           </a:p>
@@ -7268,6 +7672,7 @@
           <a:lstStyle/>
           <a:p>
             <a:pPr algn="ctr"/>
+            <a:endParaRPr/>
           </a:p>
         </p:txBody>
       </p:sp>
@@ -7280,7 +7685,7 @@
         <p:spPr>
           <a:xfrm>
             <a:off x="4526280" y="1252728"/>
-            <a:ext cx="3108960" cy="4901184"/>
+            <a:ext cx="3108960" cy="4272965"/>
           </a:xfrm>
           <a:prstGeom prst="rect">
             <a:avLst/>
@@ -7305,6 +7710,7 @@
               </a:defRPr>
             </a:pPr>
             <a:r>
+              <a:rPr sz="1200" dirty="0"/>
               <a:t>ANALYTICAL OBJECTIVES</a:t>
             </a:r>
           </a:p>
@@ -7321,8 +7727,10 @@
               </a:defRPr>
             </a:pPr>
             <a:r>
+              <a:rPr sz="1200" dirty="0"/>
               <a:t>• O1. Map Global Coverage: Plot 100% geo-valid records to expose data deserts in Southern/Indian oceans.</a:t>
             </a:r>
+            <a:endParaRPr lang="en-US" sz="1200" dirty="0"/>
           </a:p>
           <a:p>
             <a:pPr>
@@ -7336,9 +7744,25 @@
                 <a:latin typeface="Calibri"/>
               </a:defRPr>
             </a:pPr>
-            <a:r>
+            <a:endParaRPr sz="1200" dirty="0"/>
+          </a:p>
+          <a:p>
+            <a:pPr>
+              <a:spcAft>
+                <a:spcPts val="400"/>
+              </a:spcAft>
+              <a:defRPr sz="950">
+                <a:solidFill>
+                  <a:srgbClr val="1E293B"/>
+                </a:solidFill>
+                <a:latin typeface="Calibri"/>
+              </a:defRPr>
+            </a:pPr>
+            <a:r>
+              <a:rPr sz="1200" dirty="0"/>
               <a:t>• O2. Effort-Normalized Hotspots: Separate research vessel route frequency from true contamination density.</a:t>
             </a:r>
+            <a:endParaRPr lang="en-US" sz="1200" dirty="0"/>
           </a:p>
           <a:p>
             <a:pPr>
@@ -7352,9 +7776,25 @@
                 <a:latin typeface="Calibri"/>
               </a:defRPr>
             </a:pPr>
-            <a:r>
+            <a:endParaRPr sz="1200" dirty="0"/>
+          </a:p>
+          <a:p>
+            <a:pPr>
+              <a:spcAft>
+                <a:spcPts val="400"/>
+              </a:spcAft>
+              <a:defRPr sz="950">
+                <a:solidFill>
+                  <a:srgbClr val="1E293B"/>
+                </a:solidFill>
+                <a:latin typeface="Calibri"/>
+              </a:defRPr>
+            </a:pPr>
+            <a:r>
+              <a:rPr sz="1200" dirty="0"/>
               <a:t>• O3. Decompose 50-Year Trends: Deconstruct 1972–2026 data to separate sampling growth from pollution rise.</a:t>
             </a:r>
+            <a:endParaRPr lang="en-US" sz="1200" dirty="0"/>
           </a:p>
           <a:p>
             <a:pPr>
@@ -7368,9 +7808,25 @@
                 <a:latin typeface="Calibri"/>
               </a:defRPr>
             </a:pPr>
-            <a:r>
+            <a:endParaRPr sz="1200" dirty="0"/>
+          </a:p>
+          <a:p>
+            <a:pPr>
+              <a:spcAft>
+                <a:spcPts val="400"/>
+              </a:spcAft>
+              <a:defRPr sz="950">
+                <a:solidFill>
+                  <a:srgbClr val="1E293B"/>
+                </a:solidFill>
+                <a:latin typeface="Calibri"/>
+              </a:defRPr>
+            </a:pPr>
+            <a:r>
+              <a:rPr sz="1200" dirty="0"/>
               <a:t>• O4. Compare Ocean Basins: Quantify median and IQR concentration strictly within matched units.</a:t>
             </a:r>
+            <a:endParaRPr lang="en-US" sz="1200" dirty="0"/>
           </a:p>
           <a:p>
             <a:pPr>
@@ -7384,7 +7840,22 @@
                 <a:latin typeface="Calibri"/>
               </a:defRPr>
             </a:pPr>
-            <a:r>
+            <a:endParaRPr sz="1200" dirty="0"/>
+          </a:p>
+          <a:p>
+            <a:pPr>
+              <a:spcAft>
+                <a:spcPts val="400"/>
+              </a:spcAft>
+              <a:defRPr sz="950">
+                <a:solidFill>
+                  <a:srgbClr val="1E293B"/>
+                </a:solidFill>
+                <a:latin typeface="Calibri"/>
+              </a:defRPr>
+            </a:pPr>
+            <a:r>
+              <a:rPr sz="1200" dirty="0"/>
               <a:t>• O5. Assess Mesh Aperture Bias: Measure the 4x detection gap between fine filters (&lt;100 um) and standard nets (333 um).</a:t>
             </a:r>
           </a:p>
@@ -7432,6 +7903,7 @@
           <a:lstStyle/>
           <a:p>
             <a:pPr algn="ctr"/>
+            <a:endParaRPr/>
           </a:p>
         </p:txBody>
       </p:sp>
@@ -7444,7 +7916,7 @@
         <p:spPr>
           <a:xfrm>
             <a:off x="8183879" y="1252728"/>
-            <a:ext cx="3108960" cy="4901184"/>
+            <a:ext cx="3108960" cy="2939266"/>
           </a:xfrm>
           <a:prstGeom prst="rect">
             <a:avLst/>
@@ -7469,6 +7941,7 @@
               </a:defRPr>
             </a:pPr>
             <a:r>
+              <a:rPr sz="1200"/>
               <a:t>WHY THIS MATTERS</a:t>
             </a:r>
           </a:p>
@@ -7482,28 +7955,48 @@
               </a:defRPr>
             </a:pPr>
             <a:r>
+              <a:rPr sz="1200"/>
               <a:t>• Stop Wasting Resources:</a:t>
             </a:r>
-            <a:br/>
-            <a:r>
+            <a:br>
+              <a:rPr sz="1200"/>
+            </a:br>
+            <a:r>
+              <a:rPr sz="1200"/>
               <a:t>Prevents deploying cleanup operations to heavily surveyed coasts while severe pelagic gyre accumulation zones remain ignored.</a:t>
             </a:r>
-            <a:br/>
-            <a:br/>
-            <a:r>
+            <a:br>
+              <a:rPr sz="1200"/>
+            </a:br>
+            <a:br>
+              <a:rPr sz="1200"/>
+            </a:br>
+            <a:r>
+              <a:rPr sz="1200"/>
               <a:t>• Ethical Data Communication:</a:t>
             </a:r>
-            <a:br/>
-            <a:r>
+            <a:br>
+              <a:rPr sz="1200"/>
+            </a:br>
+            <a:r>
+              <a:rPr sz="1200"/>
               <a:t>Shows how chart manipulation (truncated axes, mixing units) creates false alarms and misinforms the public.</a:t>
             </a:r>
-            <a:br/>
-            <a:br/>
-            <a:r>
+            <a:br>
+              <a:rPr sz="1200"/>
+            </a:br>
+            <a:br>
+              <a:rPr sz="1200"/>
+            </a:br>
+            <a:r>
+              <a:rPr sz="1200"/>
               <a:t>• Policy Support:</a:t>
             </a:r>
-            <a:br/>
-            <a:r>
+            <a:br>
+              <a:rPr sz="1200"/>
+            </a:br>
+            <a:r>
+              <a:rPr sz="1200"/>
               <a:t>Provides sound empirical evidence for the UN Global Plastics Treaty (INC-5) and IMO plastic pellet rules.</a:t>
             </a:r>
           </a:p>
@@ -7518,7 +8011,7 @@
 </file>
 
 <file path=ppt/slides/slide3.xml><?xml version="1.0" encoding="utf-8"?>
-<p:sld xmlns:a="http://schemas.openxmlformats.org/drawingml/2006/main" xmlns:p="http://schemas.openxmlformats.org/presentationml/2006/main" xmlns:r="http://schemas.openxmlformats.org/officeDocument/2006/relationships">
+<p:sld xmlns:a="http://schemas.openxmlformats.org/drawingml/2006/main" xmlns:r="http://schemas.openxmlformats.org/officeDocument/2006/relationships" xmlns:p="http://schemas.openxmlformats.org/presentationml/2006/main">
   <p:cSld>
     <p:spTree>
       <p:nvGrpSpPr>
@@ -7526,7 +8019,14 @@
         <p:cNvGrpSpPr/>
         <p:nvPr/>
       </p:nvGrpSpPr>
-      <p:grpSpPr/>
+      <p:grpSpPr>
+        <a:xfrm>
+          <a:off x="0" y="0"/>
+          <a:ext cx="0" cy="0"/>
+          <a:chOff x="0" y="0"/>
+          <a:chExt cx="0" cy="0"/>
+        </a:xfrm>
+      </p:grpSpPr>
       <p:sp>
         <p:nvSpPr>
           <p:cNvPr id="2" name="Rectangle 1"/>
@@ -7567,6 +8067,7 @@
           <a:lstStyle/>
           <a:p>
             <a:pPr algn="ctr"/>
+            <a:endParaRPr/>
           </a:p>
         </p:txBody>
       </p:sp>
@@ -7682,6 +8183,7 @@
           <a:lstStyle/>
           <a:p>
             <a:pPr algn="ctr"/>
+            <a:endParaRPr/>
           </a:p>
         </p:txBody>
       </p:sp>
@@ -7799,6 +8301,7 @@
           <a:lstStyle/>
           <a:p>
             <a:pPr algn="ctr"/>
+            <a:endParaRPr/>
           </a:p>
         </p:txBody>
       </p:sp>
@@ -7811,7 +8314,7 @@
         <p:spPr>
           <a:xfrm>
             <a:off x="914400" y="1234440"/>
-            <a:ext cx="10332720" cy="3383280"/>
+            <a:ext cx="10332720" cy="2718693"/>
           </a:xfrm>
           <a:prstGeom prst="rect">
             <a:avLst/>
@@ -7836,16 +8339,22 @@
               </a:defRPr>
             </a:pPr>
             <a:r>
+              <a:rPr sz="1200" dirty="0"/>
               <a:t>DATASET SOURCE: </a:t>
             </a:r>
             <a:r>
-              <a:rPr b="0">
+              <a:rPr sz="1200" b="0" dirty="0">
                 <a:solidFill>
                   <a:srgbClr val="1E293B"/>
                 </a:solidFill>
               </a:rPr>
               <a:t>NOAA National Centers for Environmental Information (NCEI) Global Marine Microplastics Database (Parent Collection DOI: 10.25921/d1bs-3m40; Nurdle Patrol Accession: 0259486).</a:t>
             </a:r>
+            <a:endParaRPr lang="en-US" sz="1200" b="0" dirty="0">
+              <a:solidFill>
+                <a:srgbClr val="1E293B"/>
+              </a:solidFill>
+            </a:endParaRPr>
           </a:p>
           <a:p>
             <a:pPr>
@@ -7859,17 +8368,41 @@
                 <a:latin typeface="Calibri"/>
               </a:defRPr>
             </a:pPr>
-            <a:r>
+            <a:endParaRPr sz="1200" b="0" dirty="0">
+              <a:solidFill>
+                <a:srgbClr val="1E293B"/>
+              </a:solidFill>
+            </a:endParaRPr>
+          </a:p>
+          <a:p>
+            <a:pPr>
+              <a:spcAft>
+                <a:spcPts val="400"/>
+              </a:spcAft>
+              <a:defRPr sz="1050" b="1">
+                <a:solidFill>
+                  <a:srgbClr val="18334F"/>
+                </a:solidFill>
+                <a:latin typeface="Calibri"/>
+              </a:defRPr>
+            </a:pPr>
+            <a:r>
+              <a:rPr sz="1200" dirty="0"/>
               <a:t>DOMAIN &amp; COVERAGE: </a:t>
             </a:r>
             <a:r>
-              <a:rPr b="0">
+              <a:rPr sz="1200" b="0" dirty="0">
                 <a:solidFill>
                   <a:srgbClr val="1E293B"/>
                 </a:solidFill>
               </a:rPr>
               <a:t>Global Marine Environmental Pollution. Spans all 5 major oceans (Atlantic, Pacific, Indian, Arctic, Southern) from latitude -54° to +81°.</a:t>
             </a:r>
+            <a:endParaRPr lang="en-US" sz="1200" b="0" dirty="0">
+              <a:solidFill>
+                <a:srgbClr val="1E293B"/>
+              </a:solidFill>
+            </a:endParaRPr>
           </a:p>
           <a:p>
             <a:pPr>
@@ -7883,17 +8416,41 @@
                 <a:latin typeface="Calibri"/>
               </a:defRPr>
             </a:pPr>
-            <a:r>
+            <a:endParaRPr sz="1200" b="0" dirty="0">
+              <a:solidFill>
+                <a:srgbClr val="1E293B"/>
+              </a:solidFill>
+            </a:endParaRPr>
+          </a:p>
+          <a:p>
+            <a:pPr>
+              <a:spcAft>
+                <a:spcPts val="400"/>
+              </a:spcAft>
+              <a:defRPr sz="1050" b="1">
+                <a:solidFill>
+                  <a:srgbClr val="18334F"/>
+                </a:solidFill>
+                <a:latin typeface="Calibri"/>
+              </a:defRPr>
+            </a:pPr>
+            <a:r>
+              <a:rPr sz="1200" dirty="0"/>
               <a:t>TEMPORAL SCOPE: </a:t>
             </a:r>
             <a:r>
-              <a:rPr b="0">
+              <a:rPr sz="1200" b="0" dirty="0">
                 <a:solidFill>
                   <a:srgbClr val="1E293B"/>
                 </a:solidFill>
               </a:rPr>
               <a:t>54-year continuous baseline from April 20, 1972 through April 28, 2026. Blends professional research voyages and standardized citizen science.</a:t>
             </a:r>
+            <a:endParaRPr lang="en-US" sz="1200" b="0" dirty="0">
+              <a:solidFill>
+                <a:srgbClr val="1E293B"/>
+              </a:solidFill>
+            </a:endParaRPr>
           </a:p>
           <a:p>
             <a:pPr>
@@ -7907,17 +8464,57 @@
                 <a:latin typeface="Calibri"/>
               </a:defRPr>
             </a:pPr>
-            <a:r>
+            <a:endParaRPr sz="1200" b="0" dirty="0">
+              <a:solidFill>
+                <a:srgbClr val="1E293B"/>
+              </a:solidFill>
+            </a:endParaRPr>
+          </a:p>
+          <a:p>
+            <a:pPr>
+              <a:spcAft>
+                <a:spcPts val="400"/>
+              </a:spcAft>
+              <a:defRPr sz="1050" b="1">
+                <a:solidFill>
+                  <a:srgbClr val="18334F"/>
+                </a:solidFill>
+                <a:latin typeface="Calibri"/>
+              </a:defRPr>
+            </a:pPr>
+            <a:r>
+              <a:rPr sz="1200" dirty="0"/>
               <a:t>KEY ATTRIBUTES &amp; TYPES: </a:t>
             </a:r>
             <a:r>
-              <a:rPr b="0">
+              <a:rPr sz="1200" b="0" dirty="0">
                 <a:solidFill>
                   <a:srgbClr val="1E293B"/>
                 </a:solidFill>
               </a:rPr>
-              <a:t>Sample Date (DateTime), Lat/Lon (Decimal degrees), Ocean (Categorical), Marine Setting (Categorical: 4 levels), Sampling Method (Categorical), Mesh Size (Numeric mm), Measurement Value (Numeric), Unit (Categorical: 3 distinct units), Concentration Class (Ordinal: Very Low to Very High).</a:t>
-            </a:r>
+              <a:t>Sample Date (</a:t>
+            </a:r>
+            <a:r>
+              <a:rPr sz="1200" b="0" dirty="0" err="1">
+                <a:solidFill>
+                  <a:srgbClr val="1E293B"/>
+                </a:solidFill>
+              </a:rPr>
+              <a:t>DateTime</a:t>
+            </a:r>
+            <a:r>
+              <a:rPr sz="1200" b="0" dirty="0">
+                <a:solidFill>
+                  <a:srgbClr val="1E293B"/>
+                </a:solidFill>
+              </a:rPr>
+              <a:t>), Lat/Lon (Decimal degrees), Ocean (Categorical), Marine Setting (Categorical: 4 levels), Sampling Method (Categorical), Mesh Size (Numeric mm), Measurement Value (Numeric), Unit (Categorical: 3 distinct units), Concentration Class (Ordinal: Very Low to Very High).</a:t>
+            </a:r>
+            <a:endParaRPr lang="en-US" sz="1200" b="0" dirty="0">
+              <a:solidFill>
+                <a:srgbClr val="1E293B"/>
+              </a:solidFill>
+            </a:endParaRPr>
           </a:p>
           <a:p>
             <a:pPr>
@@ -7931,16 +8528,51 @@
                 <a:latin typeface="Calibri"/>
               </a:defRPr>
             </a:pPr>
-            <a:r>
+            <a:endParaRPr sz="1200" b="0" dirty="0">
+              <a:solidFill>
+                <a:srgbClr val="1E293B"/>
+              </a:solidFill>
+            </a:endParaRPr>
+          </a:p>
+          <a:p>
+            <a:pPr>
+              <a:spcAft>
+                <a:spcPts val="400"/>
+              </a:spcAft>
+              <a:defRPr sz="1050" b="1">
+                <a:solidFill>
+                  <a:srgbClr val="18334F"/>
+                </a:solidFill>
+                <a:latin typeface="Calibri"/>
+              </a:defRPr>
+            </a:pPr>
+            <a:r>
+              <a:rPr sz="1200" dirty="0"/>
               <a:t>DATA QUALITY CONCERNS: </a:t>
             </a:r>
             <a:r>
-              <a:rPr b="0">
+              <a:rPr sz="1200" b="0" dirty="0">
                 <a:solidFill>
                   <a:srgbClr val="1E293B"/>
                 </a:solidFill>
               </a:rPr>
-              <a:t>1) Incompatible Units (pieces/m3, pieces/10 mins, pieces kg-1 d.w.) tied to settings. 2) Severe Spatial Sampling Bias (94.2% in Northern Hemisphere). 3) Heavy Right Skew spanning 6 orders of magnitude.</a:t>
+              <a:t>1) Incompatible Units (pieces/m3, pieces/10 mins, pieces kg-1 </a:t>
+            </a:r>
+            <a:r>
+              <a:rPr sz="1200" b="0" dirty="0" err="1">
+                <a:solidFill>
+                  <a:srgbClr val="1E293B"/>
+                </a:solidFill>
+              </a:rPr>
+              <a:t>d.w</a:t>
+            </a:r>
+            <a:r>
+              <a:rPr sz="1200" b="0" dirty="0">
+                <a:solidFill>
+                  <a:srgbClr val="1E293B"/>
+                </a:solidFill>
+              </a:rPr>
+              <a:t>.) tied to settings. 2) Severe Spatial Sampling Bias (94.2% in Northern Hemisphere). 3) Heavy Right Skew spanning 6 orders of magnitude.</a:t>
             </a:r>
           </a:p>
         </p:txBody>
@@ -7987,6 +8619,7 @@
           <a:lstStyle/>
           <a:p>
             <a:pPr algn="ctr"/>
+            <a:endParaRPr/>
           </a:p>
         </p:txBody>
       </p:sp>
@@ -8094,6 +8727,7 @@
           <a:lstStyle/>
           <a:p>
             <a:pPr algn="ctr"/>
+            <a:endParaRPr/>
           </a:p>
         </p:txBody>
       </p:sp>
@@ -8201,6 +8835,7 @@
           <a:lstStyle/>
           <a:p>
             <a:pPr algn="ctr"/>
+            <a:endParaRPr/>
           </a:p>
         </p:txBody>
       </p:sp>
@@ -8308,6 +8943,7 @@
           <a:lstStyle/>
           <a:p>
             <a:pPr algn="ctr"/>
+            <a:endParaRPr/>
           </a:p>
         </p:txBody>
       </p:sp>
@@ -8382,7 +9018,7 @@
 </file>
 
 <file path=ppt/slides/slide4.xml><?xml version="1.0" encoding="utf-8"?>
-<p:sld xmlns:a="http://schemas.openxmlformats.org/drawingml/2006/main" xmlns:p="http://schemas.openxmlformats.org/presentationml/2006/main" xmlns:r="http://schemas.openxmlformats.org/officeDocument/2006/relationships">
+<p:sld xmlns:a="http://schemas.openxmlformats.org/drawingml/2006/main" xmlns:r="http://schemas.openxmlformats.org/officeDocument/2006/relationships" xmlns:p="http://schemas.openxmlformats.org/presentationml/2006/main">
   <p:cSld>
     <p:spTree>
       <p:nvGrpSpPr>
@@ -8390,7 +9026,14 @@
         <p:cNvGrpSpPr/>
         <p:nvPr/>
       </p:nvGrpSpPr>
-      <p:grpSpPr/>
+      <p:grpSpPr>
+        <a:xfrm>
+          <a:off x="0" y="0"/>
+          <a:ext cx="0" cy="0"/>
+          <a:chOff x="0" y="0"/>
+          <a:chExt cx="0" cy="0"/>
+        </a:xfrm>
+      </p:grpSpPr>
       <p:sp>
         <p:nvSpPr>
           <p:cNvPr id="2" name="Rectangle 1"/>
@@ -8431,6 +9074,7 @@
           <a:lstStyle/>
           <a:p>
             <a:pPr algn="ctr"/>
+            <a:endParaRPr/>
           </a:p>
         </p:txBody>
       </p:sp>
@@ -8546,6 +9190,7 @@
           <a:lstStyle/>
           <a:p>
             <a:pPr algn="ctr"/>
+            <a:endParaRPr sz="1200"/>
           </a:p>
         </p:txBody>
       </p:sp>
@@ -8663,6 +9308,7 @@
           <a:lstStyle/>
           <a:p>
             <a:pPr algn="ctr"/>
+            <a:endParaRPr sz="1200"/>
           </a:p>
         </p:txBody>
       </p:sp>
@@ -8675,7 +9321,7 @@
         <p:spPr>
           <a:xfrm>
             <a:off x="841248" y="1216152"/>
-            <a:ext cx="3163824" cy="2276856"/>
+            <a:ext cx="3163824" cy="1487587"/>
           </a:xfrm>
           <a:prstGeom prst="rect">
             <a:avLst/>
@@ -8700,6 +9346,7 @@
               </a:defRPr>
             </a:pPr>
             <a:r>
+              <a:rPr sz="1200"/>
               <a:t>1. COORDINATE VALIDATION</a:t>
             </a:r>
           </a:p>
@@ -8716,6 +9363,7 @@
               </a:defRPr>
             </a:pPr>
             <a:r>
+              <a:rPr sz="1200"/>
               <a:t>• Checked all latitudes in [-90, +90] and longitudes in [-180, +180].</a:t>
             </a:r>
           </a:p>
@@ -8732,6 +9380,7 @@
               </a:defRPr>
             </a:pPr>
             <a:r>
+              <a:rPr sz="1200"/>
               <a:t>• 29,076 of 29,076 records (100.0%) passed validation with zero missing coordinates.</a:t>
             </a:r>
           </a:p>
@@ -8748,6 +9397,7 @@
               </a:defRPr>
             </a:pPr>
             <a:r>
+              <a:rPr sz="1200"/>
               <a:t>• Reconciled geographic coordinates with pre-projected Web Mercator values.</a:t>
             </a:r>
           </a:p>
@@ -8795,6 +9445,7 @@
           <a:lstStyle/>
           <a:p>
             <a:pPr algn="ctr"/>
+            <a:endParaRPr sz="1200"/>
           </a:p>
         </p:txBody>
       </p:sp>
@@ -8807,7 +9458,7 @@
         <p:spPr>
           <a:xfrm>
             <a:off x="4480560" y="1216152"/>
-            <a:ext cx="3163824" cy="2276856"/>
+            <a:ext cx="3163824" cy="1487587"/>
           </a:xfrm>
           <a:prstGeom prst="rect">
             <a:avLst/>
@@ -8832,6 +9483,7 @@
               </a:defRPr>
             </a:pPr>
             <a:r>
+              <a:rPr sz="1200"/>
               <a:t>2. DATE STANDARDIZATION</a:t>
             </a:r>
           </a:p>
@@ -8848,6 +9500,7 @@
               </a:defRPr>
             </a:pPr>
             <a:r>
+              <a:rPr sz="1200"/>
               <a:t>• Converted string timestamps into ISO-8601 datetimes.</a:t>
             </a:r>
           </a:p>
@@ -8864,6 +9517,7 @@
               </a:defRPr>
             </a:pPr>
             <a:r>
+              <a:rPr sz="1200"/>
               <a:t>• Derived temporal features: Year, Month, Decade, and pre/post-2010 sampling eras.</a:t>
             </a:r>
           </a:p>
@@ -8880,6 +9534,7 @@
               </a:defRPr>
             </a:pPr>
             <a:r>
+              <a:rPr sz="1200"/>
               <a:t>• Preserved historical records dating back to 1972.</a:t>
             </a:r>
           </a:p>
@@ -8927,6 +9582,7 @@
           <a:lstStyle/>
           <a:p>
             <a:pPr algn="ctr"/>
+            <a:endParaRPr sz="1200"/>
           </a:p>
         </p:txBody>
       </p:sp>
@@ -8939,7 +9595,7 @@
         <p:spPr>
           <a:xfrm>
             <a:off x="8119872" y="1216152"/>
-            <a:ext cx="3163824" cy="2276856"/>
+            <a:ext cx="3163824" cy="1277273"/>
           </a:xfrm>
           <a:prstGeom prst="rect">
             <a:avLst/>
@@ -8964,6 +9620,7 @@
               </a:defRPr>
             </a:pPr>
             <a:r>
+              <a:rPr sz="1200"/>
               <a:t>3. MISSING VALUE STRATEGY</a:t>
             </a:r>
           </a:p>
@@ -8980,6 +9637,7 @@
               </a:defRPr>
             </a:pPr>
             <a:r>
+              <a:rPr sz="1200"/>
               <a:t>• Missing-Not-At-Random (MNAR): fields like volunteer count and sample depth are naturally empty for open-ocean net tows.</a:t>
             </a:r>
           </a:p>
@@ -8996,6 +9654,7 @@
               </a:defRPr>
             </a:pPr>
             <a:r>
+              <a:rPr sz="1200"/>
               <a:t>• Retained as explicit 'Not Recorded' category rather than using false imputation.</a:t>
             </a:r>
           </a:p>
@@ -9043,6 +9702,7 @@
           <a:lstStyle/>
           <a:p>
             <a:pPr algn="ctr"/>
+            <a:endParaRPr sz="1200"/>
           </a:p>
         </p:txBody>
       </p:sp>
@@ -9055,7 +9715,7 @@
         <p:spPr>
           <a:xfrm>
             <a:off x="841248" y="3822192"/>
-            <a:ext cx="3163824" cy="2276856"/>
+            <a:ext cx="3163824" cy="1933863"/>
           </a:xfrm>
           <a:prstGeom prst="rect">
             <a:avLst/>
@@ -9080,6 +9740,7 @@
               </a:defRPr>
             </a:pPr>
             <a:r>
+              <a:rPr sz="1200"/>
               <a:t>4. STRICT UNIT SEGREGATION</a:t>
             </a:r>
           </a:p>
@@ -9096,6 +9757,7 @@
               </a:defRPr>
             </a:pPr>
             <a:r>
+              <a:rPr sz="1200"/>
               <a:t>• CRITICAL RULE: Measurements are strictly separated by Marine Setting:</a:t>
             </a:r>
           </a:p>
@@ -9112,6 +9774,7 @@
               </a:defRPr>
             </a:pPr>
             <a:r>
+              <a:rPr sz="1200"/>
               <a:t>  - Ocean Water: pieces/m³ (16,988 records)</a:t>
             </a:r>
           </a:p>
@@ -9128,6 +9791,7 @@
               </a:defRPr>
             </a:pPr>
             <a:r>
+              <a:rPr sz="1200"/>
               <a:t>  - Nurdle Patrol: pieces/10 mins (10,615 records)</a:t>
             </a:r>
           </a:p>
@@ -9144,6 +9808,7 @@
               </a:defRPr>
             </a:pPr>
             <a:r>
+              <a:rPr sz="1200"/>
               <a:t>  - Beach: pieces/m³ sand (893 records)</a:t>
             </a:r>
           </a:p>
@@ -9160,6 +9825,7 @@
               </a:defRPr>
             </a:pPr>
             <a:r>
+              <a:rPr sz="1200"/>
               <a:t>  - Sediment: pieces kg⁻¹ d.w. (580 records)</a:t>
             </a:r>
           </a:p>
@@ -9176,6 +9842,7 @@
               </a:defRPr>
             </a:pPr>
             <a:r>
+              <a:rPr sz="1200"/>
               <a:t>• Zero cross-unit numeric pooling.</a:t>
             </a:r>
           </a:p>
@@ -9223,6 +9890,7 @@
           <a:lstStyle/>
           <a:p>
             <a:pPr algn="ctr"/>
+            <a:endParaRPr sz="1200"/>
           </a:p>
         </p:txBody>
       </p:sp>
@@ -9235,7 +9903,7 @@
         <p:spPr>
           <a:xfrm>
             <a:off x="4480560" y="3822192"/>
-            <a:ext cx="3163824" cy="2276856"/>
+            <a:ext cx="3163824" cy="1277273"/>
           </a:xfrm>
           <a:prstGeom prst="rect">
             <a:avLst/>
@@ -9260,6 +9928,7 @@
               </a:defRPr>
             </a:pPr>
             <a:r>
+              <a:rPr sz="1200"/>
               <a:t>5. SKEWNESS &amp; LOG-TRANSFORM</a:t>
             </a:r>
           </a:p>
@@ -9276,6 +9945,7 @@
               </a:defRPr>
             </a:pPr>
             <a:r>
+              <a:rPr sz="1200"/>
               <a:t>• Microplastic concentrations span 6 orders of magnitude (0.001 to &gt;10,000).</a:t>
             </a:r>
           </a:p>
@@ -9292,6 +9962,7 @@
               </a:defRPr>
             </a:pPr>
             <a:r>
+              <a:rPr sz="1200"/>
               <a:t>• Created log10(conc + 1) transformed fields for statistical testing while preserving raw metrics for reporting.</a:t>
             </a:r>
           </a:p>
@@ -9339,6 +10010,7 @@
           <a:lstStyle/>
           <a:p>
             <a:pPr algn="ctr"/>
+            <a:endParaRPr sz="1200"/>
           </a:p>
         </p:txBody>
       </p:sp>
@@ -9351,7 +10023,7 @@
         <p:spPr>
           <a:xfrm>
             <a:off x="8119872" y="3822192"/>
-            <a:ext cx="3163824" cy="2276856"/>
+            <a:ext cx="3163824" cy="1277273"/>
           </a:xfrm>
           <a:prstGeom prst="rect">
             <a:avLst/>
@@ -9376,6 +10048,7 @@
               </a:defRPr>
             </a:pPr>
             <a:r>
+              <a:rPr sz="1200"/>
               <a:t>6. 2°×2° SPATIAL GRID FEATURE</a:t>
             </a:r>
           </a:p>
@@ -9392,6 +10065,7 @@
               </a:defRPr>
             </a:pPr>
             <a:r>
+              <a:rPr sz="1200"/>
               <a:t>• Created 2°×2° spatial grid bins to calculate observation count per cell.</a:t>
             </a:r>
           </a:p>
@@ -9408,6 +10082,7 @@
               </a:defRPr>
             </a:pPr>
             <a:r>
+              <a:rPr sz="1200"/>
               <a:t>• Enables effort-normalization: dividing total particles by sample density to find true hotspots.</a:t>
             </a:r>
           </a:p>
@@ -9422,7 +10097,7 @@
 </file>
 
 <file path=ppt/slides/slide5.xml><?xml version="1.0" encoding="utf-8"?>
-<p:sld xmlns:a="http://schemas.openxmlformats.org/drawingml/2006/main" xmlns:p="http://schemas.openxmlformats.org/presentationml/2006/main" xmlns:r="http://schemas.openxmlformats.org/officeDocument/2006/relationships">
+<p:sld xmlns:a="http://schemas.openxmlformats.org/drawingml/2006/main" xmlns:r="http://schemas.openxmlformats.org/officeDocument/2006/relationships" xmlns:p="http://schemas.openxmlformats.org/presentationml/2006/main">
   <p:cSld>
     <p:spTree>
       <p:nvGrpSpPr>
@@ -9430,7 +10105,14 @@
         <p:cNvGrpSpPr/>
         <p:nvPr/>
       </p:nvGrpSpPr>
-      <p:grpSpPr/>
+      <p:grpSpPr>
+        <a:xfrm>
+          <a:off x="0" y="0"/>
+          <a:ext cx="0" cy="0"/>
+          <a:chOff x="0" y="0"/>
+          <a:chExt cx="0" cy="0"/>
+        </a:xfrm>
+      </p:grpSpPr>
       <p:sp>
         <p:nvSpPr>
           <p:cNvPr id="2" name="Rectangle 1"/>
@@ -9471,6 +10153,7 @@
           <a:lstStyle/>
           <a:p>
             <a:pPr algn="ctr"/>
+            <a:endParaRPr/>
           </a:p>
         </p:txBody>
       </p:sp>
@@ -9518,7 +10201,7 @@
         </p:nvSpPr>
         <p:spPr>
           <a:xfrm>
-            <a:off x="731520" y="402336"/>
+            <a:off x="636927" y="374904"/>
             <a:ext cx="10698480" cy="502920"/>
           </a:xfrm>
           <a:prstGeom prst="rect">
@@ -9586,6 +10269,7 @@
           <a:lstStyle/>
           <a:p>
             <a:pPr algn="ctr"/>
+            <a:endParaRPr/>
           </a:p>
         </p:txBody>
       </p:sp>
@@ -9669,11 +10353,13 @@
         </p:nvSpPr>
         <p:spPr>
           <a:xfrm>
-            <a:off x="731520" y="1143000"/>
-            <a:ext cx="3383280" cy="5029200"/>
+            <a:off x="1385683" y="1133856"/>
+            <a:ext cx="4182697" cy="5029200"/>
           </a:xfrm>
           <a:prstGeom prst="roundRect">
-            <a:avLst/>
+            <a:avLst>
+              <a:gd name="adj" fmla="val 9430"/>
+            </a:avLst>
           </a:prstGeom>
           <a:solidFill>
             <a:srgbClr val="EEF5F8"/>
@@ -9703,6 +10389,7 @@
           <a:lstStyle/>
           <a:p>
             <a:pPr algn="ctr"/>
+            <a:endParaRPr/>
           </a:p>
         </p:txBody>
       </p:sp>
@@ -9714,8 +10401,8 @@
         </p:nvSpPr>
         <p:spPr>
           <a:xfrm>
-            <a:off x="868680" y="1252728"/>
-            <a:ext cx="3108960" cy="4809744"/>
+            <a:off x="1581280" y="1613443"/>
+            <a:ext cx="3734851" cy="3011081"/>
           </a:xfrm>
           <a:prstGeom prst="rect">
             <a:avLst/>
@@ -9737,6 +10424,7 @@
               </a:defRPr>
             </a:pPr>
             <a:r>
+              <a:rPr sz="1200" dirty="0"/>
               <a:t>TOOL 1: PYTHON VISUALIZATION</a:t>
             </a:r>
           </a:p>
@@ -9753,6 +10441,7 @@
               </a:defRPr>
             </a:pPr>
             <a:r>
+              <a:rPr sz="1200" dirty="0"/>
               <a:t>Matplotlib &amp; Seaborn</a:t>
             </a:r>
           </a:p>
@@ -9769,6 +10458,7 @@
               </a:defRPr>
             </a:pPr>
             <a:r>
+              <a:rPr sz="1200" dirty="0"/>
               <a:t>WHY SELECTED:</a:t>
             </a:r>
           </a:p>
@@ -9785,6 +10475,7 @@
               </a:defRPr>
             </a:pPr>
             <a:r>
+              <a:rPr sz="1200" dirty="0"/>
               <a:t>• Full coordinate control for geographic scatter projection.</a:t>
             </a:r>
           </a:p>
@@ -9801,6 +10492,7 @@
               </a:defRPr>
             </a:pPr>
             <a:r>
+              <a:rPr sz="1200" dirty="0"/>
               <a:t>• Non-parametric distribution modeling (boxplots, violins, LOESS regression).</a:t>
             </a:r>
           </a:p>
@@ -9817,6 +10509,7 @@
               </a:defRPr>
             </a:pPr>
             <a:r>
+              <a:rPr sz="1200" dirty="0"/>
               <a:t>• Enables forensic side-by-side ethical chart redesign.</a:t>
             </a:r>
           </a:p>
@@ -9832,6 +10525,7 @@
                 <a:latin typeface="Calibri"/>
               </a:defRPr>
             </a:pPr>
+            <a:endParaRPr sz="1200" dirty="0"/>
           </a:p>
           <a:p>
             <a:pPr>
@@ -9846,6 +10540,7 @@
               </a:defRPr>
             </a:pPr>
             <a:r>
+              <a:rPr sz="1200" dirty="0"/>
               <a:t>WHAT IT PRODUCES:</a:t>
             </a:r>
           </a:p>
@@ -9862,6 +10557,7 @@
               </a:defRPr>
             </a:pPr>
             <a:r>
+              <a:rPr sz="1200" dirty="0"/>
               <a:t>• V1 Global Map &amp; V2 Effort-Aware Grid</a:t>
             </a:r>
           </a:p>
@@ -9878,6 +10574,7 @@
               </a:defRPr>
             </a:pPr>
             <a:r>
+              <a:rPr sz="1200" dirty="0"/>
               <a:t>• V3 50-Year Trajectory &amp; V4 Basin Distributions</a:t>
             </a:r>
           </a:p>
@@ -9894,6 +10591,7 @@
               </a:defRPr>
             </a:pPr>
             <a:r>
+              <a:rPr sz="1200" dirty="0"/>
               <a:t>• V5 Setting Profile, V6/V7 Gear &amp; Mesh Biases</a:t>
             </a:r>
           </a:p>
@@ -9910,6 +10608,7 @@
               </a:defRPr>
             </a:pPr>
             <a:r>
+              <a:rPr sz="1200" dirty="0"/>
               <a:t>• V8 Severity Matrix &amp; V9 Ethical Redesign</a:t>
             </a:r>
           </a:p>
@@ -9923,11 +10622,13 @@
         </p:nvSpPr>
         <p:spPr>
           <a:xfrm>
-            <a:off x="4370832" y="1143000"/>
-            <a:ext cx="3383280" cy="5029200"/>
+            <a:off x="6142246" y="1208900"/>
+            <a:ext cx="4664070" cy="5029200"/>
           </a:xfrm>
           <a:prstGeom prst="roundRect">
-            <a:avLst/>
+            <a:avLst>
+              <a:gd name="adj" fmla="val 8960"/>
+            </a:avLst>
           </a:prstGeom>
           <a:solidFill>
             <a:srgbClr val="EEF5F8"/>
@@ -9957,6 +10658,7 @@
           <a:lstStyle/>
           <a:p>
             <a:pPr algn="ctr"/>
+            <a:endParaRPr/>
           </a:p>
         </p:txBody>
       </p:sp>
@@ -9968,8 +10670,8 @@
         </p:nvSpPr>
         <p:spPr>
           <a:xfrm>
-            <a:off x="4507992" y="1252728"/>
-            <a:ext cx="3108960" cy="4809744"/>
+            <a:off x="6456610" y="1613443"/>
+            <a:ext cx="3876110" cy="3195747"/>
           </a:xfrm>
           <a:prstGeom prst="rect">
             <a:avLst/>
@@ -9991,6 +10693,7 @@
               </a:defRPr>
             </a:pPr>
             <a:r>
+              <a:rPr sz="1200" dirty="0"/>
               <a:t>TOOL 2: POWER BI DESKTOP</a:t>
             </a:r>
           </a:p>
@@ -10007,7 +10710,16 @@
               </a:defRPr>
             </a:pPr>
             <a:r>
-              <a:t>Enterprise Business Intelligence (.pbip)</a:t>
+              <a:rPr sz="1200" dirty="0"/>
+              <a:t>Enterprise Business Intelligence (.</a:t>
+            </a:r>
+            <a:r>
+              <a:rPr sz="1200" dirty="0" err="1"/>
+              <a:t>pbip</a:t>
+            </a:r>
+            <a:r>
+              <a:rPr sz="1200" dirty="0"/>
+              <a:t>)</a:t>
             </a:r>
           </a:p>
           <a:p>
@@ -10023,6 +10735,7 @@
               </a:defRPr>
             </a:pPr>
             <a:r>
+              <a:rPr sz="1200" dirty="0"/>
               <a:t>WHY SELECTED:</a:t>
             </a:r>
           </a:p>
@@ -10039,6 +10752,7 @@
               </a:defRPr>
             </a:pPr>
             <a:r>
+              <a:rPr sz="1200" dirty="0"/>
               <a:t>• Interactive delivery for decision-makers with zero code execution.</a:t>
             </a:r>
           </a:p>
@@ -10055,6 +10769,7 @@
               </a:defRPr>
             </a:pPr>
             <a:r>
+              <a:rPr sz="1200" dirty="0"/>
               <a:t>• Certified Star Schema data model (1 Fact table, 6 Dimension tables).</a:t>
             </a:r>
           </a:p>
@@ -10071,6 +10786,7 @@
               </a:defRPr>
             </a:pPr>
             <a:r>
+              <a:rPr sz="1200" dirty="0"/>
               <a:t>• 15+ custom DAX measures enforcing unit isolation &amp; dynamic filtering.</a:t>
             </a:r>
           </a:p>
@@ -10086,6 +10802,7 @@
                 <a:latin typeface="Calibri"/>
               </a:defRPr>
             </a:pPr>
+            <a:endParaRPr sz="1200" dirty="0"/>
           </a:p>
           <a:p>
             <a:pPr>
@@ -10100,6 +10817,7 @@
               </a:defRPr>
             </a:pPr>
             <a:r>
+              <a:rPr sz="1200" dirty="0"/>
               <a:t>WHAT IT PRODUCES:</a:t>
             </a:r>
           </a:p>
@@ -10116,6 +10834,7 @@
               </a:defRPr>
             </a:pPr>
             <a:r>
+              <a:rPr sz="1200" dirty="0"/>
               <a:t>• Page 1: Executive KPI Overview &amp; Spatial Map</a:t>
             </a:r>
           </a:p>
@@ -10132,6 +10851,7 @@
               </a:defRPr>
             </a:pPr>
             <a:r>
+              <a:rPr sz="1200" dirty="0"/>
               <a:t>• Page 2: Ocean Basin &amp; Setting Deep-Dive</a:t>
             </a:r>
           </a:p>
@@ -10148,6 +10868,7 @@
               </a:defRPr>
             </a:pPr>
             <a:r>
+              <a:rPr sz="1200" dirty="0"/>
               <a:t>• Page 3: Provenance &amp; Ethical Audit Visualizer</a:t>
             </a:r>
           </a:p>
@@ -10164,245 +10885,8 @@
               </a:defRPr>
             </a:pPr>
             <a:r>
+              <a:rPr sz="1200" dirty="0"/>
               <a:t>• Interactive cross-filtering slicers &amp; drill-down</a:t>
-            </a:r>
-          </a:p>
-        </p:txBody>
-      </p:sp>
-      <p:sp>
-        <p:nvSpPr>
-          <p:cNvPr id="12" name="Rounded Rectangle 11"/>
-          <p:cNvSpPr/>
-          <p:nvPr/>
-        </p:nvSpPr>
-        <p:spPr>
-          <a:xfrm>
-            <a:off x="8010144" y="1143000"/>
-            <a:ext cx="3383280" cy="5029200"/>
-          </a:xfrm>
-          <a:prstGeom prst="roundRect">
-            <a:avLst/>
-          </a:prstGeom>
-          <a:solidFill>
-            <a:srgbClr val="EEF5F8"/>
-          </a:solidFill>
-          <a:ln>
-            <a:solidFill>
-              <a:srgbClr val="CBD5E1"/>
-            </a:solidFill>
-          </a:ln>
-        </p:spPr>
-        <p:style>
-          <a:lnRef idx="1">
-            <a:schemeClr val="accent1"/>
-          </a:lnRef>
-          <a:fillRef idx="3">
-            <a:schemeClr val="accent1"/>
-          </a:fillRef>
-          <a:effectRef idx="2">
-            <a:schemeClr val="accent1"/>
-          </a:effectRef>
-          <a:fontRef idx="minor">
-            <a:schemeClr val="lt1"/>
-          </a:fontRef>
-        </p:style>
-        <p:txBody>
-          <a:bodyPr rtlCol="0" anchor="ctr"/>
-          <a:lstStyle/>
-          <a:p>
-            <a:pPr algn="ctr"/>
-          </a:p>
-        </p:txBody>
-      </p:sp>
-      <p:sp>
-        <p:nvSpPr>
-          <p:cNvPr id="13" name="TextBox 12"/>
-          <p:cNvSpPr txBox="1"/>
-          <p:nvPr/>
-        </p:nvSpPr>
-        <p:spPr>
-          <a:xfrm>
-            <a:off x="8147304" y="1252728"/>
-            <a:ext cx="3108960" cy="4809744"/>
-          </a:xfrm>
-          <a:prstGeom prst="rect">
-            <a:avLst/>
-          </a:prstGeom>
-          <a:noFill/>
-        </p:spPr>
-        <p:txBody>
-          <a:bodyPr wrap="square">
-            <a:spAutoFit/>
-          </a:bodyPr>
-          <a:lstStyle/>
-          <a:p>
-            <a:pPr>
-              <a:defRPr sz="1150" b="1">
-                <a:solidFill>
-                  <a:srgbClr val="18334F"/>
-                </a:solidFill>
-                <a:latin typeface="Calibri"/>
-              </a:defRPr>
-            </a:pPr>
-            <a:r>
-              <a:t>TOOL 3: PLOTLY WEB ENGINE</a:t>
-            </a:r>
-          </a:p>
-          <a:p>
-            <a:pPr>
-              <a:spcAft>
-                <a:spcPts val="800"/>
-              </a:spcAft>
-              <a:defRPr sz="950" b="1">
-                <a:solidFill>
-                  <a:srgbClr val="147483"/>
-                </a:solidFill>
-                <a:latin typeface="Calibri"/>
-              </a:defRPr>
-            </a:pPr>
-            <a:r>
-              <a:t>WebGL &amp; D3.js Standalone HTML</a:t>
-            </a:r>
-          </a:p>
-          <a:p>
-            <a:pPr>
-              <a:spcAft>
-                <a:spcPts val="200"/>
-              </a:spcAft>
-              <a:defRPr sz="950" b="1">
-                <a:solidFill>
-                  <a:srgbClr val="147483"/>
-                </a:solidFill>
-                <a:latin typeface="Calibri"/>
-              </a:defRPr>
-            </a:pPr>
-            <a:r>
-              <a:t>WHY SELECTED:</a:t>
-            </a:r>
-          </a:p>
-          <a:p>
-            <a:pPr>
-              <a:spcAft>
-                <a:spcPts val="200"/>
-              </a:spcAft>
-              <a:defRPr sz="950">
-                <a:solidFill>
-                  <a:srgbClr val="18334F"/>
-                </a:solidFill>
-                <a:latin typeface="Calibri"/>
-              </a:defRPr>
-            </a:pPr>
-            <a:r>
-              <a:t>• Zero-dependency web viewing in any standard browser (Chrome, Edge, Safari).</a:t>
-            </a:r>
-          </a:p>
-          <a:p>
-            <a:pPr>
-              <a:spcAft>
-                <a:spcPts val="200"/>
-              </a:spcAft>
-              <a:defRPr sz="950">
-                <a:solidFill>
-                  <a:srgbClr val="18334F"/>
-                </a:solidFill>
-                <a:latin typeface="Calibri"/>
-              </a:defRPr>
-            </a:pPr>
-            <a:r>
-              <a:t>• Hardware-accelerated rendering of all 29,076 coordinates.</a:t>
-            </a:r>
-          </a:p>
-          <a:p>
-            <a:pPr>
-              <a:spcAft>
-                <a:spcPts val="200"/>
-              </a:spcAft>
-              <a:defRPr sz="950">
-                <a:solidFill>
-                  <a:srgbClr val="18334F"/>
-                </a:solidFill>
-                <a:latin typeface="Calibri"/>
-              </a:defRPr>
-            </a:pPr>
-            <a:r>
-              <a:t>• Dynamic hover tooltips and interactive zooming for rapid inspection.</a:t>
-            </a:r>
-          </a:p>
-          <a:p>
-            <a:pPr>
-              <a:spcAft>
-                <a:spcPts val="200"/>
-              </a:spcAft>
-              <a:defRPr sz="950">
-                <a:solidFill>
-                  <a:srgbClr val="1E293B"/>
-                </a:solidFill>
-                <a:latin typeface="Calibri"/>
-              </a:defRPr>
-            </a:pPr>
-          </a:p>
-          <a:p>
-            <a:pPr>
-              <a:spcAft>
-                <a:spcPts val="200"/>
-              </a:spcAft>
-              <a:defRPr sz="950" b="1">
-                <a:solidFill>
-                  <a:srgbClr val="147483"/>
-                </a:solidFill>
-                <a:latin typeface="Calibri"/>
-              </a:defRPr>
-            </a:pPr>
-            <a:r>
-              <a:t>WHAT IT PRODUCES:</a:t>
-            </a:r>
-          </a:p>
-          <a:p>
-            <a:pPr>
-              <a:spcAft>
-                <a:spcPts val="200"/>
-              </a:spcAft>
-              <a:defRPr sz="950">
-                <a:solidFill>
-                  <a:srgbClr val="18334F"/>
-                </a:solidFill>
-                <a:latin typeface="Calibri"/>
-              </a:defRPr>
-            </a:pPr>
-            <a:r>
-              <a:t>• Standalone single-file HTML dashboard</a:t>
-            </a:r>
-          </a:p>
-          <a:p>
-            <a:pPr>
-              <a:spcAft>
-                <a:spcPts val="200"/>
-              </a:spcAft>
-              <a:defRPr sz="950">
-                <a:solidFill>
-                  <a:srgbClr val="18334F"/>
-                </a:solidFill>
-                <a:latin typeface="Calibri"/>
-              </a:defRPr>
-            </a:pPr>
-            <a:r>
-              <a:t>• Cross-linked scatter and bar views</a:t>
-            </a:r>
-          </a:p>
-          <a:p>
-            <a:pPr>
-              <a:spcAft>
-                <a:spcPts val="200"/>
-              </a:spcAft>
-              <a:defRPr sz="950">
-                <a:solidFill>
-                  <a:srgbClr val="18334F"/>
-                </a:solidFill>
-                <a:latin typeface="Calibri"/>
-              </a:defRPr>
-            </a:pPr>
-            <a:r>
-              <a:t>• Dynamic multi-select marine setting filters</a:t>
             </a:r>
           </a:p>
         </p:txBody>
@@ -10416,7 +10900,7 @@
 </file>
 
 <file path=ppt/slides/slide6.xml><?xml version="1.0" encoding="utf-8"?>
-<p:sld xmlns:a="http://schemas.openxmlformats.org/drawingml/2006/main" xmlns:p="http://schemas.openxmlformats.org/presentationml/2006/main" xmlns:r="http://schemas.openxmlformats.org/officeDocument/2006/relationships">
+<p:sld xmlns:a="http://schemas.openxmlformats.org/drawingml/2006/main" xmlns:r="http://schemas.openxmlformats.org/officeDocument/2006/relationships" xmlns:p="http://schemas.openxmlformats.org/presentationml/2006/main">
   <p:cSld>
     <p:spTree>
       <p:nvGrpSpPr>
@@ -10424,7 +10908,14 @@
         <p:cNvGrpSpPr/>
         <p:nvPr/>
       </p:nvGrpSpPr>
-      <p:grpSpPr/>
+      <p:grpSpPr>
+        <a:xfrm>
+          <a:off x="0" y="0"/>
+          <a:ext cx="0" cy="0"/>
+          <a:chOff x="0" y="0"/>
+          <a:chExt cx="0" cy="0"/>
+        </a:xfrm>
+      </p:grpSpPr>
       <p:sp>
         <p:nvSpPr>
           <p:cNvPr id="2" name="Rectangle 1"/>
@@ -10465,6 +10956,7 @@
           <a:lstStyle/>
           <a:p>
             <a:pPr algn="ctr"/>
+            <a:endParaRPr/>
           </a:p>
         </p:txBody>
       </p:sp>
@@ -10580,6 +11072,7 @@
           <a:lstStyle/>
           <a:p>
             <a:pPr algn="ctr"/>
+            <a:endParaRPr/>
           </a:p>
         </p:txBody>
       </p:sp>
@@ -10667,7 +11160,9 @@
             <a:ext cx="5212080" cy="5120640"/>
           </a:xfrm>
           <a:prstGeom prst="roundRect">
-            <a:avLst/>
+            <a:avLst>
+              <a:gd name="adj" fmla="val 5830"/>
+            </a:avLst>
           </a:prstGeom>
           <a:solidFill>
             <a:srgbClr val="FFFFFF"/>
@@ -10697,6 +11192,7 @@
           <a:lstStyle/>
           <a:p>
             <a:pPr algn="ctr"/>
+            <a:endParaRPr/>
           </a:p>
         </p:txBody>
       </p:sp>
@@ -10709,7 +11205,7 @@
         <p:spPr>
           <a:xfrm>
             <a:off x="868680" y="1234440"/>
-            <a:ext cx="4937760" cy="1005840"/>
+            <a:ext cx="4937760" cy="1200329"/>
           </a:xfrm>
           <a:prstGeom prst="rect">
             <a:avLst/>
@@ -10731,6 +11227,7 @@
               </a:defRPr>
             </a:pPr>
             <a:r>
+              <a:rPr sz="1200" dirty="0"/>
               <a:t>V1: GLOBAL SAMPLING MAP &amp; GEOGRAPHIC BIAS</a:t>
             </a:r>
           </a:p>
@@ -10744,11 +11241,23 @@
               </a:defRPr>
             </a:pPr>
             <a:r>
+              <a:rPr sz="1200" dirty="0"/>
               <a:t>Description: Global scatter plot of all 29,076 sampling locations color-coded by marine setting.</a:t>
             </a:r>
-            <a:br/>
-            <a:r>
-              <a:t>Insight: 94.2% of records cluster in the Northern Hemisphere (North Atlantic &amp; Gulf of Mexico). Indian Ocean (2.7%) and Southern Ocean (0.1%) are critical data blindspots.</a:t>
+            <a:br>
+              <a:rPr sz="1200" dirty="0"/>
+            </a:br>
+            <a:r>
+              <a:rPr sz="1200" dirty="0"/>
+              <a:t>Insight: 94.2% of records cluster in the Northern Hemisphere (North Atlantic &amp; Gulf of Mexico). Indian Ocean (2.7%) and Southern Ocean (0.1%) are critical data </a:t>
+            </a:r>
+            <a:r>
+              <a:rPr sz="1200" dirty="0" err="1"/>
+              <a:t>blindspots</a:t>
+            </a:r>
+            <a:r>
+              <a:rPr sz="1200" dirty="0"/>
+              <a:t>.</a:t>
             </a:r>
           </a:p>
         </p:txBody>
@@ -10844,7 +11353,9 @@
             <a:ext cx="5212080" cy="5120640"/>
           </a:xfrm>
           <a:prstGeom prst="roundRect">
-            <a:avLst/>
+            <a:avLst>
+              <a:gd name="adj" fmla="val 6692"/>
+            </a:avLst>
           </a:prstGeom>
           <a:solidFill>
             <a:srgbClr val="FFFFFF"/>
@@ -10874,6 +11385,7 @@
           <a:lstStyle/>
           <a:p>
             <a:pPr algn="ctr"/>
+            <a:endParaRPr/>
           </a:p>
         </p:txBody>
       </p:sp>
@@ -10886,7 +11398,7 @@
         <p:spPr>
           <a:xfrm>
             <a:off x="6355080" y="1234440"/>
-            <a:ext cx="4937760" cy="1005840"/>
+            <a:ext cx="4937760" cy="1200329"/>
           </a:xfrm>
           <a:prstGeom prst="rect">
             <a:avLst/>
@@ -10908,6 +11420,7 @@
               </a:defRPr>
             </a:pPr>
             <a:r>
+              <a:rPr sz="1200" dirty="0"/>
               <a:t>V2: HOTSPOT ANALYSIS: EFFORT VS. POLLUTION</a:t>
             </a:r>
           </a:p>
@@ -10921,10 +11434,14 @@
               </a:defRPr>
             </a:pPr>
             <a:r>
+              <a:rPr sz="1200" dirty="0"/>
               <a:t>Description: 2°×2° binned spatial grid separating sample count from median concentration.</a:t>
             </a:r>
-            <a:br/>
-            <a:r>
+            <a:br>
+              <a:rPr sz="1200" dirty="0"/>
+            </a:br>
+            <a:r>
+              <a:rPr sz="1200" dirty="0"/>
               <a:t>Insight: Normalizing effort reveals that coastal Florida and English Channel are heavily sampled, not heavily polluted. True hotspots lie in pelagic gyres (e.g. North Pacific) with extreme concentrations.</a:t>
             </a:r>
           </a:p>
@@ -10946,7 +11463,7 @@
         </p:blipFill>
         <p:spPr>
           <a:xfrm>
-            <a:off x="6355080" y="2423160"/>
+            <a:off x="6355080" y="3072699"/>
             <a:ext cx="4937760" cy="1895278"/>
           </a:xfrm>
           <a:prstGeom prst="rect">
@@ -11018,7 +11535,7 @@
 </file>
 
 <file path=ppt/slides/slide7.xml><?xml version="1.0" encoding="utf-8"?>
-<p:sld xmlns:a="http://schemas.openxmlformats.org/drawingml/2006/main" xmlns:p="http://schemas.openxmlformats.org/presentationml/2006/main" xmlns:r="http://schemas.openxmlformats.org/officeDocument/2006/relationships">
+<p:sld xmlns:a="http://schemas.openxmlformats.org/drawingml/2006/main" xmlns:r="http://schemas.openxmlformats.org/officeDocument/2006/relationships" xmlns:p="http://schemas.openxmlformats.org/presentationml/2006/main">
   <p:cSld>
     <p:spTree>
       <p:nvGrpSpPr>
@@ -11026,7 +11543,14 @@
         <p:cNvGrpSpPr/>
         <p:nvPr/>
       </p:nvGrpSpPr>
-      <p:grpSpPr/>
+      <p:grpSpPr>
+        <a:xfrm>
+          <a:off x="0" y="0"/>
+          <a:ext cx="0" cy="0"/>
+          <a:chOff x="0" y="0"/>
+          <a:chExt cx="0" cy="0"/>
+        </a:xfrm>
+      </p:grpSpPr>
       <p:sp>
         <p:nvSpPr>
           <p:cNvPr id="2" name="Rectangle 1"/>
@@ -11067,6 +11591,7 @@
           <a:lstStyle/>
           <a:p>
             <a:pPr algn="ctr"/>
+            <a:endParaRPr/>
           </a:p>
         </p:txBody>
       </p:sp>
@@ -11182,6 +11707,7 @@
           <a:lstStyle/>
           <a:p>
             <a:pPr algn="ctr"/>
+            <a:endParaRPr/>
           </a:p>
         </p:txBody>
       </p:sp>
@@ -11269,7 +11795,9 @@
             <a:ext cx="5212080" cy="5120640"/>
           </a:xfrm>
           <a:prstGeom prst="roundRect">
-            <a:avLst/>
+            <a:avLst>
+              <a:gd name="adj" fmla="val 8416"/>
+            </a:avLst>
           </a:prstGeom>
           <a:solidFill>
             <a:srgbClr val="FFFFFF"/>
@@ -11299,6 +11827,7 @@
           <a:lstStyle/>
           <a:p>
             <a:pPr algn="ctr"/>
+            <a:endParaRPr/>
           </a:p>
         </p:txBody>
       </p:sp>
@@ -11333,6 +11862,7 @@
               </a:defRPr>
             </a:pPr>
             <a:r>
+              <a:rPr sz="1000" dirty="0"/>
               <a:t>V3: 50-YEAR MONITORING TRAJECTORY (1972–2026)</a:t>
             </a:r>
           </a:p>
@@ -11346,10 +11876,14 @@
               </a:defRPr>
             </a:pPr>
             <a:r>
+              <a:rPr sz="1000" dirty="0"/>
               <a:t>Description: Dual-axis time series of annual observation count vs. median ocean water concentration.</a:t>
             </a:r>
-            <a:br/>
-            <a:r>
+            <a:br>
+              <a:rPr sz="1000" dirty="0"/>
+            </a:br>
+            <a:r>
+              <a:rPr sz="1000" dirty="0"/>
               <a:t>Insight: Record counts explode after 2010 due to citizen science (Nurdle Patrol) and research funding. Decoupling count from concentration shows baseline contamination remained steady, not an abrupt overnight surge.</a:t>
             </a:r>
           </a:p>
@@ -11446,7 +11980,9 @@
             <a:ext cx="5212080" cy="5120640"/>
           </a:xfrm>
           <a:prstGeom prst="roundRect">
-            <a:avLst/>
+            <a:avLst>
+              <a:gd name="adj" fmla="val 8785"/>
+            </a:avLst>
           </a:prstGeom>
           <a:solidFill>
             <a:srgbClr val="FFFFFF"/>
@@ -11476,6 +12012,7 @@
           <a:lstStyle/>
           <a:p>
             <a:pPr algn="ctr"/>
+            <a:endParaRPr/>
           </a:p>
         </p:txBody>
       </p:sp>
@@ -11488,7 +12025,7 @@
         <p:spPr>
           <a:xfrm>
             <a:off x="6355080" y="1234440"/>
-            <a:ext cx="4937760" cy="1005840"/>
+            <a:ext cx="4937760" cy="1200329"/>
           </a:xfrm>
           <a:prstGeom prst="rect">
             <a:avLst/>
@@ -11510,6 +12047,7 @@
               </a:defRPr>
             </a:pPr>
             <a:r>
+              <a:rPr sz="1200" dirty="0"/>
               <a:t>V4: CONCENTRATION ACROSS 5 OCEAN BASINS</a:t>
             </a:r>
           </a:p>
@@ -11523,10 +12061,14 @@
               </a:defRPr>
             </a:pPr>
             <a:r>
+              <a:rPr sz="1200" dirty="0"/>
               <a:t>Description: Log10-scale box and violin plots comparing surface water microplastic levels across ocean basins.</a:t>
             </a:r>
-            <a:br/>
-            <a:r>
+            <a:br>
+              <a:rPr sz="1200" dirty="0"/>
+            </a:br>
+            <a:r>
+              <a:rPr sz="1200" dirty="0"/>
               <a:t>Insight: Kruskal-Wallis test (H = 142.8, p &lt; 0.001) confirms significant inter-basin differences. Pacific Ocean exhibits the highest median concentration (1.84 pcs/m³); Mediterranean shows extreme upper-tail outliers.</a:t>
             </a:r>
           </a:p>
@@ -11548,7 +12090,7 @@
         </p:blipFill>
         <p:spPr>
           <a:xfrm>
-            <a:off x="6355080" y="2514600"/>
+            <a:off x="6355080" y="2701861"/>
             <a:ext cx="4937760" cy="1915860"/>
           </a:xfrm>
           <a:prstGeom prst="rect">
@@ -11620,7 +12162,7 @@
 </file>
 
 <file path=ppt/slides/slide8.xml><?xml version="1.0" encoding="utf-8"?>
-<p:sld xmlns:a="http://schemas.openxmlformats.org/drawingml/2006/main" xmlns:p="http://schemas.openxmlformats.org/presentationml/2006/main" xmlns:r="http://schemas.openxmlformats.org/officeDocument/2006/relationships">
+<p:sld xmlns:a="http://schemas.openxmlformats.org/drawingml/2006/main" xmlns:r="http://schemas.openxmlformats.org/officeDocument/2006/relationships" xmlns:p="http://schemas.openxmlformats.org/presentationml/2006/main">
   <p:cSld>
     <p:spTree>
       <p:nvGrpSpPr>
@@ -11628,7 +12170,14 @@
         <p:cNvGrpSpPr/>
         <p:nvPr/>
       </p:nvGrpSpPr>
-      <p:grpSpPr/>
+      <p:grpSpPr>
+        <a:xfrm>
+          <a:off x="0" y="0"/>
+          <a:ext cx="0" cy="0"/>
+          <a:chOff x="0" y="0"/>
+          <a:chExt cx="0" cy="0"/>
+        </a:xfrm>
+      </p:grpSpPr>
       <p:sp>
         <p:nvSpPr>
           <p:cNvPr id="2" name="Rectangle 1"/>
@@ -11669,6 +12218,7 @@
           <a:lstStyle/>
           <a:p>
             <a:pPr algn="ctr"/>
+            <a:endParaRPr/>
           </a:p>
         </p:txBody>
       </p:sp>
@@ -11784,6 +12334,7 @@
           <a:lstStyle/>
           <a:p>
             <a:pPr algn="ctr"/>
+            <a:endParaRPr/>
           </a:p>
         </p:txBody>
       </p:sp>
@@ -11901,6 +12452,7 @@
           <a:lstStyle/>
           <a:p>
             <a:pPr algn="ctr"/>
+            <a:endParaRPr/>
           </a:p>
         </p:txBody>
       </p:sp>
@@ -11912,8 +12464,8 @@
         </p:nvSpPr>
         <p:spPr>
           <a:xfrm>
-            <a:off x="841248" y="1216152"/>
-            <a:ext cx="2560320" cy="2286000"/>
+            <a:off x="841247" y="1216152"/>
+            <a:ext cx="4859563" cy="772006"/>
           </a:xfrm>
           <a:prstGeom prst="rect">
             <a:avLst/>
@@ -11938,6 +12490,7 @@
               </a:defRPr>
             </a:pPr>
             <a:r>
+              <a:rPr sz="1000" dirty="0"/>
               <a:t>V5: ALL 4 MARINE SETTINGS COMPARED</a:t>
             </a:r>
           </a:p>
@@ -11954,6 +12507,7 @@
               </a:defRPr>
             </a:pPr>
             <a:r>
+              <a:rPr sz="1000" dirty="0"/>
               <a:t>Desc: Distribution across Water, Beach, Sediment, and Nurdles.</a:t>
             </a:r>
           </a:p>
@@ -11967,6 +12521,7 @@
               </a:defRPr>
             </a:pPr>
             <a:r>
+              <a:rPr sz="1000" dirty="0"/>
               <a:t>Insight: Beach sand median (1,280 pcs/m³) is orders of magnitude higher than surface ocean water (0.01 pcs/m³). Proves units must never be pooled.</a:t>
             </a:r>
           </a:p>
@@ -11988,8 +12543,8 @@
         </p:blipFill>
         <p:spPr>
           <a:xfrm>
-            <a:off x="3429000" y="1280160"/>
-            <a:ext cx="2423160" cy="843332"/>
+            <a:off x="1280160" y="2050743"/>
+            <a:ext cx="4000620" cy="1392335"/>
           </a:xfrm>
           <a:prstGeom prst="rect">
             <a:avLst/>
@@ -12038,6 +12593,7 @@
           <a:lstStyle/>
           <a:p>
             <a:pPr algn="ctr"/>
+            <a:endParaRPr/>
           </a:p>
         </p:txBody>
       </p:sp>
@@ -12050,7 +12606,7 @@
         <p:spPr>
           <a:xfrm>
             <a:off x="6327648" y="1216152"/>
-            <a:ext cx="2560320" cy="2286000"/>
+            <a:ext cx="4783888" cy="772006"/>
           </a:xfrm>
           <a:prstGeom prst="rect">
             <a:avLst/>
@@ -12075,6 +12631,7 @@
               </a:defRPr>
             </a:pPr>
             <a:r>
+              <a:rPr sz="1000" dirty="0"/>
               <a:t>V6: SAMPLING METHOD BY BASIN MATRIX</a:t>
             </a:r>
           </a:p>
@@ -12091,6 +12648,7 @@
               </a:defRPr>
             </a:pPr>
             <a:r>
+              <a:rPr sz="1000" dirty="0"/>
               <a:t>Desc: Cross-tabulation of sampling gear across ocean basins.</a:t>
             </a:r>
           </a:p>
@@ -12104,6 +12662,7 @@
               </a:defRPr>
             </a:pPr>
             <a:r>
+              <a:rPr sz="1000" dirty="0"/>
               <a:t>Insight: Severe method-geography confounding: Manta nets dominate open Atlantic cruises, whereas nearshore grab samples dominate enclosed coastal seas.</a:t>
             </a:r>
           </a:p>
@@ -12125,8 +12684,8 @@
         </p:blipFill>
         <p:spPr>
           <a:xfrm>
-            <a:off x="8915400" y="1280160"/>
-            <a:ext cx="2423160" cy="1312545"/>
+            <a:off x="7255028" y="1931416"/>
+            <a:ext cx="2790759" cy="1511662"/>
           </a:xfrm>
           <a:prstGeom prst="rect">
             <a:avLst/>
@@ -12175,6 +12734,7 @@
           <a:lstStyle/>
           <a:p>
             <a:pPr algn="ctr"/>
+            <a:endParaRPr/>
           </a:p>
         </p:txBody>
       </p:sp>
@@ -12187,7 +12747,7 @@
         <p:spPr>
           <a:xfrm>
             <a:off x="841248" y="3867912"/>
-            <a:ext cx="2560320" cy="2286000"/>
+            <a:ext cx="4903706" cy="925894"/>
           </a:xfrm>
           <a:prstGeom prst="rect">
             <a:avLst/>
@@ -12212,6 +12772,7 @@
               </a:defRPr>
             </a:pPr>
             <a:r>
+              <a:rPr sz="1000" dirty="0"/>
               <a:t>V7: MESH SIZE APERTURE BIAS (0.333 mm)</a:t>
             </a:r>
           </a:p>
@@ -12228,6 +12789,7 @@
               </a:defRPr>
             </a:pPr>
             <a:r>
+              <a:rPr sz="1000" dirty="0"/>
               <a:t>Desc: Microplastic capture concentration vs. net mesh aperture size.</a:t>
             </a:r>
           </a:p>
@@ -12241,6 +12803,7 @@
               </a:defRPr>
             </a:pPr>
             <a:r>
+              <a:rPr sz="1000" dirty="0"/>
               <a:t>Insight: Nets finer than 100 um detect over 4x higher microplastic concentrations (especially microfibers) than standard 333 um manta nets, proving systematic undercounting.</a:t>
             </a:r>
           </a:p>
@@ -12262,8 +12825,8 @@
         </p:blipFill>
         <p:spPr>
           <a:xfrm>
-            <a:off x="3429000" y="3931920"/>
-            <a:ext cx="2423160" cy="908978"/>
+            <a:off x="1620694" y="4732870"/>
+            <a:ext cx="3727283" cy="1398182"/>
           </a:xfrm>
           <a:prstGeom prst="rect">
             <a:avLst/>
@@ -12312,6 +12875,7 @@
           <a:lstStyle/>
           <a:p>
             <a:pPr algn="ctr"/>
+            <a:endParaRPr/>
           </a:p>
         </p:txBody>
       </p:sp>
@@ -12323,8 +12887,8 @@
         </p:nvSpPr>
         <p:spPr>
           <a:xfrm>
-            <a:off x="6327648" y="3867912"/>
-            <a:ext cx="2560320" cy="2286000"/>
+            <a:off x="6327647" y="3867912"/>
+            <a:ext cx="4783889" cy="772006"/>
           </a:xfrm>
           <a:prstGeom prst="rect">
             <a:avLst/>
@@ -12349,6 +12913,7 @@
               </a:defRPr>
             </a:pPr>
             <a:r>
+              <a:rPr sz="1000" dirty="0"/>
               <a:t>V8: SEVERITY BREAKDOWN ACROSS BASINS</a:t>
             </a:r>
           </a:p>
@@ -12365,6 +12930,7 @@
               </a:defRPr>
             </a:pPr>
             <a:r>
+              <a:rPr sz="1000" dirty="0"/>
               <a:t>Desc: Proportional 100% stacked bar chart of pollution severity categories.</a:t>
             </a:r>
           </a:p>
@@ -12378,6 +12944,7 @@
               </a:defRPr>
             </a:pPr>
             <a:r>
+              <a:rPr sz="1000" dirty="0"/>
               <a:t>Insight: High &amp; Very High severity classes comprise 17.7% of all global records. Pacific gyres and Mediterranean Sea show the highest severe contamination proportions.</a:t>
             </a:r>
           </a:p>
@@ -12399,8 +12966,8 @@
         </p:blipFill>
         <p:spPr>
           <a:xfrm>
-            <a:off x="8915400" y="3931920"/>
-            <a:ext cx="2423160" cy="962689"/>
+            <a:off x="6769331" y="4703256"/>
+            <a:ext cx="3593869" cy="1427796"/>
           </a:xfrm>
           <a:prstGeom prst="rect">
             <a:avLst/>
@@ -12416,7 +12983,7 @@
 </file>
 
 <file path=ppt/slides/slide9.xml><?xml version="1.0" encoding="utf-8"?>
-<p:sld xmlns:a="http://schemas.openxmlformats.org/drawingml/2006/main" xmlns:p="http://schemas.openxmlformats.org/presentationml/2006/main" xmlns:r="http://schemas.openxmlformats.org/officeDocument/2006/relationships">
+<p:sld xmlns:a="http://schemas.openxmlformats.org/drawingml/2006/main" xmlns:r="http://schemas.openxmlformats.org/officeDocument/2006/relationships" xmlns:p="http://schemas.openxmlformats.org/presentationml/2006/main">
   <p:cSld>
     <p:spTree>
       <p:nvGrpSpPr>
@@ -12424,7 +12991,14 @@
         <p:cNvGrpSpPr/>
         <p:nvPr/>
       </p:nvGrpSpPr>
-      <p:grpSpPr/>
+      <p:grpSpPr>
+        <a:xfrm>
+          <a:off x="0" y="0"/>
+          <a:ext cx="0" cy="0"/>
+          <a:chOff x="0" y="0"/>
+          <a:chExt cx="0" cy="0"/>
+        </a:xfrm>
+      </p:grpSpPr>
       <p:sp>
         <p:nvSpPr>
           <p:cNvPr id="2" name="Rectangle 1"/>
@@ -12465,6 +13039,7 @@
           <a:lstStyle/>
           <a:p>
             <a:pPr algn="ctr"/>
+            <a:endParaRPr/>
           </a:p>
         </p:txBody>
       </p:sp>
@@ -12580,6 +13155,7 @@
           <a:lstStyle/>
           <a:p>
             <a:pPr algn="ctr"/>
+            <a:endParaRPr/>
           </a:p>
         </p:txBody>
       </p:sp>
@@ -12721,6 +13297,7 @@
           <a:lstStyle/>
           <a:p>
             <a:pPr algn="ctr"/>
+            <a:endParaRPr/>
           </a:p>
         </p:txBody>
       </p:sp>
@@ -12815,6 +13392,7 @@
           <a:lstStyle/>
           <a:p>
             <a:pPr algn="ctr"/>
+            <a:endParaRPr/>
           </a:p>
         </p:txBody>
       </p:sp>
@@ -12909,6 +13487,7 @@
           <a:lstStyle/>
           <a:p>
             <a:pPr algn="ctr"/>
+            <a:endParaRPr/>
           </a:p>
         </p:txBody>
       </p:sp>
@@ -13003,6 +13582,7 @@
           <a:lstStyle/>
           <a:p>
             <a:pPr algn="ctr"/>
+            <a:endParaRPr/>
           </a:p>
         </p:txBody>
       </p:sp>

</xml_diff>